<commit_message>
docs: rebuild the Cursor training from the back-office guide
The deck now follows the company instruction: local work, plan before changes, secrets, environments, and a check before the result is saved.

Co-authored-by: Cursor <cursoragent@cursor.com>
</commit_message>
<xml_diff>
--- a/Cursor для AI Challenge.pptx
+++ b/Cursor для AI Challenge.pptx
@@ -3235,7 +3235,7 @@
         <p:spPr>
           <a:xfrm>
             <a:off x="640080" y="1234440"/>
-            <a:ext cx="4297680" cy="329184"/>
+            <a:ext cx="4892040" cy="329184"/>
           </a:xfrm>
           <a:prstGeom prst="rect">
             <a:avLst/>
@@ -3279,7 +3279,7 @@
         <p:spPr>
           <a:xfrm>
             <a:off x="749808" y="1252728"/>
-            <a:ext cx="4069080" cy="292608"/>
+            <a:ext cx="4663440" cy="292608"/>
           </a:xfrm>
           <a:prstGeom prst="rect">
             <a:avLst/>
@@ -3300,7 +3300,7 @@
                 <a:ea typeface="Arial"/>
                 <a:cs typeface="Arial"/>
               </a:rPr>
-              <a:t>AI Challenge · ОЦО и бэкофис</a:t>
+              <a:t>Обучение · бэк-офис и ОЦО</a:t>
             </a:r>
           </a:p>
         </p:txBody>
@@ -3335,8 +3335,8 @@
                 <a:ea typeface="Uncage"/>
                 <a:cs typeface="Uncage"/>
               </a:rPr>
-              <a:t>Как работать
-в Cursor</a:t>
+              <a:t>Работа
+с Cursor</a:t>
             </a:r>
           </a:p>
         </p:txBody>
@@ -3350,7 +3350,7 @@
         <p:spPr>
           <a:xfrm>
             <a:off x="640080" y="3794760"/>
-            <a:ext cx="6949440" cy="1051560"/>
+            <a:ext cx="6858000" cy="1234440"/>
           </a:xfrm>
           <a:prstGeom prst="rect">
             <a:avLst/>
@@ -3371,7 +3371,7 @@
                 <a:ea typeface="Arial"/>
                 <a:cs typeface="Arial"/>
               </a:rPr>
-              <a:t>Ставите задачу обычным языком. Агент готовит черновик в файлах проекта. Вы проверяете, что процесс и правда стал лучше.</a:t>
+              <a:t>Помощник на вашем компьютере: разбирает задачу, готовит правки и помогает проверить результат. За то, что попросили, согласовали и проверили, отвечаете вы.</a:t>
             </a:r>
           </a:p>
         </p:txBody>
@@ -3385,7 +3385,7 @@
         <p:spPr>
           <a:xfrm>
             <a:off x="640080" y="6263640"/>
-            <a:ext cx="5486400" cy="274320"/>
+            <a:ext cx="6400800" cy="274320"/>
           </a:xfrm>
           <a:prstGeom prst="rect">
             <a:avLst/>
@@ -3406,7 +3406,7 @@
                 <a:ea typeface="Arial"/>
                 <a:cs typeface="Arial"/>
               </a:rPr>
-              <a:t>Обучение · 20 октября</a:t>
+              <a:t>Откройте инструкцию перед началом задачи</a:t>
             </a:r>
           </a:p>
         </p:txBody>
@@ -3582,7 +3582,7 @@
                 <a:ea typeface="Uncage"/>
                 <a:cs typeface="Uncage"/>
               </a:rPr>
-              <a:t>Cursor работает в папке проекта</a:t>
+              <a:t>Помощник внутри вашей папки</a:t>
             </a:r>
           </a:p>
         </p:txBody>
@@ -3641,7 +3641,7 @@
                 <a:ea typeface="Arial"/>
                 <a:cs typeface="Arial"/>
               </a:rPr>
-              <a:t>AI Challenge · ОЦО и бэкофис</a:t>
+              <a:t>Бэк-офис и ОЦО · AI Challenge</a:t>
             </a:r>
           </a:p>
         </p:txBody>
@@ -3689,8 +3689,8 @@
         </p:nvSpPr>
         <p:spPr>
           <a:xfrm>
-            <a:off x="502920" y="1115568"/>
-            <a:ext cx="11155680" cy="566928"/>
+            <a:off x="502920" y="1097280"/>
+            <a:ext cx="11155680" cy="502920"/>
           </a:xfrm>
           <a:prstGeom prst="rect">
             <a:avLst/>
@@ -3711,7 +3711,7 @@
                 <a:ea typeface="Arial"/>
                 <a:cs typeface="Arial"/>
               </a:rPr>
-              <a:t>Это не отдельный чат «просто поговорить». Откройте папку, которую выдали на обучение: агент читает файлы и может их изменить. Что оставить — решаете вы.</a:t>
+              <a:t>Описываете задачу обычными словами. Cursor помогает выполнить её в открытом проекте на вашем компьютере.</a:t>
             </a:r>
           </a:p>
         </p:txBody>
@@ -3724,8 +3724,8 @@
         </p:nvSpPr>
         <p:spPr>
           <a:xfrm>
-            <a:off x="502920" y="1828800"/>
-            <a:ext cx="3611880" cy="2926080"/>
+            <a:off x="502920" y="1737360"/>
+            <a:ext cx="2697480" cy="2148840"/>
           </a:xfrm>
           <a:prstGeom prst="rect">
             <a:avLst/>
@@ -3770,8 +3770,8 @@
         </p:nvSpPr>
         <p:spPr>
           <a:xfrm>
-            <a:off x="502920" y="1828800"/>
-            <a:ext cx="3611880" cy="38100"/>
+            <a:off x="502920" y="1737360"/>
+            <a:ext cx="2697480" cy="38100"/>
           </a:xfrm>
           <a:prstGeom prst="rect">
             <a:avLst/>
@@ -3814,8 +3814,8 @@
         </p:nvSpPr>
         <p:spPr>
           <a:xfrm>
-            <a:off x="758952" y="2148840"/>
-            <a:ext cx="3017520" cy="457200"/>
+            <a:off x="667512" y="1938528"/>
+            <a:ext cx="2286000" cy="292608"/>
           </a:xfrm>
           <a:prstGeom prst="rect">
             <a:avLst/>
@@ -3828,7 +3828,7 @@
           <a:p>
             <a:pPr algn="l"/>
             <a:r>
-              <a:rPr sz="2200" b="0">
+              <a:rPr sz="1400" b="0">
                 <a:solidFill>
                   <a:srgbClr val="389BFF"/>
                 </a:solidFill>
@@ -3849,8 +3849,8 @@
         </p:nvSpPr>
         <p:spPr>
           <a:xfrm>
-            <a:off x="758952" y="2788920"/>
-            <a:ext cx="3108960" cy="731520"/>
+            <a:off x="667512" y="2267712"/>
+            <a:ext cx="2331720" cy="365760"/>
           </a:xfrm>
           <a:prstGeom prst="rect">
             <a:avLst/>
@@ -3871,7 +3871,7 @@
                 <a:ea typeface="Uncage"/>
                 <a:cs typeface="Uncage"/>
               </a:rPr>
-              <a:t>Говорите о процессе</a:t>
+              <a:t>Найти</a:t>
             </a:r>
           </a:p>
         </p:txBody>
@@ -3884,8 +3884,8 @@
         </p:nvSpPr>
         <p:spPr>
           <a:xfrm>
-            <a:off x="758952" y="3520440"/>
-            <a:ext cx="3108960" cy="1005840"/>
+            <a:off x="667512" y="2788920"/>
+            <a:ext cx="2359152" cy="868680"/>
           </a:xfrm>
           <a:prstGeom prst="rect">
             <a:avLst/>
@@ -3898,7 +3898,7 @@
           <a:p>
             <a:pPr algn="l"/>
             <a:r>
-              <a:rPr sz="1500" b="0">
+              <a:rPr sz="1400" b="0">
                 <a:solidFill>
                   <a:srgbClr val="777777"/>
                 </a:solidFill>
@@ -3906,7 +3906,7 @@
                 <a:ea typeface="Arial"/>
                 <a:cs typeface="Arial"/>
               </a:rPr>
-              <a:t>Что сейчас болит, кто делает шаг и какой результат можно показать коллегам.</a:t>
+              <a:t>Инструкцию или описание процесса в проекте.</a:t>
             </a:r>
           </a:p>
         </p:txBody>
@@ -3919,8 +3919,8 @@
         </p:nvSpPr>
         <p:spPr>
           <a:xfrm>
-            <a:off x="4297680" y="1828800"/>
-            <a:ext cx="3611880" cy="2926080"/>
+            <a:off x="3346704" y="1737360"/>
+            <a:ext cx="2697480" cy="2148840"/>
           </a:xfrm>
           <a:prstGeom prst="rect">
             <a:avLst/>
@@ -3965,8 +3965,8 @@
         </p:nvSpPr>
         <p:spPr>
           <a:xfrm>
-            <a:off x="4297680" y="1828800"/>
-            <a:ext cx="3611880" cy="38100"/>
+            <a:off x="3346704" y="1737360"/>
+            <a:ext cx="2697480" cy="38100"/>
           </a:xfrm>
           <a:prstGeom prst="rect">
             <a:avLst/>
@@ -4009,8 +4009,8 @@
         </p:nvSpPr>
         <p:spPr>
           <a:xfrm>
-            <a:off x="4553712" y="2148840"/>
-            <a:ext cx="3017520" cy="457200"/>
+            <a:off x="3511296" y="1938528"/>
+            <a:ext cx="2286000" cy="292608"/>
           </a:xfrm>
           <a:prstGeom prst="rect">
             <a:avLst/>
@@ -4023,7 +4023,7 @@
           <a:p>
             <a:pPr algn="l"/>
             <a:r>
-              <a:rPr sz="2200" b="0">
+              <a:rPr sz="1400" b="0">
                 <a:solidFill>
                   <a:srgbClr val="389BFF"/>
                 </a:solidFill>
@@ -4044,8 +4044,8 @@
         </p:nvSpPr>
         <p:spPr>
           <a:xfrm>
-            <a:off x="4553712" y="2788920"/>
-            <a:ext cx="3108960" cy="731520"/>
+            <a:off x="3511296" y="2267712"/>
+            <a:ext cx="2331720" cy="365760"/>
           </a:xfrm>
           <a:prstGeom prst="rect">
             <a:avLst/>
@@ -4066,7 +4066,7 @@
                 <a:ea typeface="Uncage"/>
                 <a:cs typeface="Uncage"/>
               </a:rPr>
-              <a:t>Агент делает черновик</a:t>
+              <a:t>Подготовить</a:t>
             </a:r>
           </a:p>
         </p:txBody>
@@ -4079,8 +4079,8 @@
         </p:nvSpPr>
         <p:spPr>
           <a:xfrm>
-            <a:off x="4553712" y="3520440"/>
-            <a:ext cx="3108960" cy="1005840"/>
+            <a:off x="3511296" y="2788920"/>
+            <a:ext cx="2359152" cy="868680"/>
           </a:xfrm>
           <a:prstGeom prst="rect">
             <a:avLst/>
@@ -4093,7 +4093,7 @@
           <a:p>
             <a:pPr algn="l"/>
             <a:r>
-              <a:rPr sz="1500" b="0">
+              <a:rPr sz="1400" b="0">
                 <a:solidFill>
                   <a:srgbClr val="777777"/>
                 </a:solidFill>
@@ -4101,7 +4101,7 @@
                 <a:ea typeface="Arial"/>
                 <a:cs typeface="Arial"/>
               </a:rPr>
-              <a:t>Ищет файлы, предлагает правки и вносит их. Новая тема — новый чат.</a:t>
+              <a:t>Правку во внутренней системе или автоматизации.</a:t>
             </a:r>
           </a:p>
         </p:txBody>
@@ -4114,8 +4114,8 @@
         </p:nvSpPr>
         <p:spPr>
           <a:xfrm>
-            <a:off x="8092440" y="1828800"/>
-            <a:ext cx="3611880" cy="2926080"/>
+            <a:off x="6190488" y="1737360"/>
+            <a:ext cx="2697480" cy="2148840"/>
           </a:xfrm>
           <a:prstGeom prst="rect">
             <a:avLst/>
@@ -4160,8 +4160,8 @@
         </p:nvSpPr>
         <p:spPr>
           <a:xfrm>
-            <a:off x="8092440" y="1828800"/>
-            <a:ext cx="3611880" cy="38100"/>
+            <a:off x="6190488" y="1737360"/>
+            <a:ext cx="2697480" cy="38100"/>
           </a:xfrm>
           <a:prstGeom prst="rect">
             <a:avLst/>
@@ -4204,8 +4204,8 @@
         </p:nvSpPr>
         <p:spPr>
           <a:xfrm>
-            <a:off x="8348472" y="2148840"/>
-            <a:ext cx="3017520" cy="457200"/>
+            <a:off x="6355080" y="1938528"/>
+            <a:ext cx="2286000" cy="292608"/>
           </a:xfrm>
           <a:prstGeom prst="rect">
             <a:avLst/>
@@ -4218,7 +4218,7 @@
           <a:p>
             <a:pPr algn="l"/>
             <a:r>
-              <a:rPr sz="2200" b="0">
+              <a:rPr sz="1400" b="0">
                 <a:solidFill>
                   <a:srgbClr val="389BFF"/>
                 </a:solidFill>
@@ -4239,8 +4239,8 @@
         </p:nvSpPr>
         <p:spPr>
           <a:xfrm>
-            <a:off x="8348472" y="2788920"/>
-            <a:ext cx="3108960" cy="731520"/>
+            <a:off x="6355080" y="2267712"/>
+            <a:ext cx="2331720" cy="365760"/>
           </a:xfrm>
           <a:prstGeom prst="rect">
             <a:avLst/>
@@ -4261,7 +4261,7 @@
                 <a:ea typeface="Uncage"/>
                 <a:cs typeface="Uncage"/>
               </a:rPr>
-              <a:t>Вы принимаете работу</a:t>
+              <a:t>Показать</a:t>
             </a:r>
           </a:p>
         </p:txBody>
@@ -4274,8 +4274,8 @@
         </p:nvSpPr>
         <p:spPr>
           <a:xfrm>
-            <a:off x="8348472" y="3520440"/>
-            <a:ext cx="3108960" cy="1005840"/>
+            <a:off x="6355080" y="2788920"/>
+            <a:ext cx="2359152" cy="868680"/>
           </a:xfrm>
           <a:prstGeom prst="rect">
             <a:avLst/>
@@ -4288,7 +4288,7 @@
           <a:p>
             <a:pPr algn="l"/>
             <a:r>
-              <a:rPr sz="1500" b="0">
+              <a:rPr sz="1400" b="0">
                 <a:solidFill>
                   <a:srgbClr val="777777"/>
                 </a:solidFill>
@@ -4296,7 +4296,7 @@
                 <a:ea typeface="Arial"/>
                 <a:cs typeface="Arial"/>
               </a:rPr>
-              <a:t>Откройте результат и пройдите сценарий. Не сошлось — напишите, что поправить.</a:t>
+              <a:t>Что именно изменилось после работы.</a:t>
             </a:r>
           </a:p>
         </p:txBody>
@@ -4309,8 +4309,203 @@
         </p:nvSpPr>
         <p:spPr>
           <a:xfrm>
-            <a:off x="502920" y="4956048"/>
-            <a:ext cx="11173968" cy="1005840"/>
+            <a:off x="9034272" y="1737360"/>
+            <a:ext cx="2697480" cy="2148840"/>
+          </a:xfrm>
+          <a:prstGeom prst="rect">
+            <a:avLst/>
+          </a:prstGeom>
+          <a:solidFill>
+            <a:srgbClr val="FFFFFF"/>
+          </a:solidFill>
+          <a:ln w="9525">
+            <a:solidFill>
+              <a:srgbClr val="E0E3E8"/>
+            </a:solidFill>
+          </a:ln>
+          <a:effectLst/>
+        </p:spPr>
+        <p:style>
+          <a:lnRef idx="1">
+            <a:schemeClr val="accent1"/>
+          </a:lnRef>
+          <a:fillRef idx="3">
+            <a:schemeClr val="accent1"/>
+          </a:fillRef>
+          <a:effectRef idx="2">
+            <a:schemeClr val="accent1"/>
+          </a:effectRef>
+          <a:fontRef idx="minor">
+            <a:schemeClr val="lt1"/>
+          </a:fontRef>
+        </p:style>
+        <p:txBody>
+          <a:bodyPr rtlCol="0" anchor="ctr"/>
+          <a:lstStyle/>
+          <a:p>
+            <a:pPr algn="ctr"/>
+          </a:p>
+        </p:txBody>
+      </p:sp>
+      <p:sp>
+        <p:nvSpPr>
+          <p:cNvPr id="26" name="Rectangle 25"/>
+          <p:cNvSpPr/>
+          <p:nvPr/>
+        </p:nvSpPr>
+        <p:spPr>
+          <a:xfrm>
+            <a:off x="9034272" y="1737360"/>
+            <a:ext cx="2697480" cy="38100"/>
+          </a:xfrm>
+          <a:prstGeom prst="rect">
+            <a:avLst/>
+          </a:prstGeom>
+          <a:solidFill>
+            <a:srgbClr val="389BFF"/>
+          </a:solidFill>
+          <a:ln>
+            <a:noFill/>
+          </a:ln>
+          <a:effectLst/>
+        </p:spPr>
+        <p:style>
+          <a:lnRef idx="1">
+            <a:schemeClr val="accent1"/>
+          </a:lnRef>
+          <a:fillRef idx="3">
+            <a:schemeClr val="accent1"/>
+          </a:fillRef>
+          <a:effectRef idx="2">
+            <a:schemeClr val="accent1"/>
+          </a:effectRef>
+          <a:fontRef idx="minor">
+            <a:schemeClr val="lt1"/>
+          </a:fontRef>
+        </p:style>
+        <p:txBody>
+          <a:bodyPr rtlCol="0" anchor="ctr"/>
+          <a:lstStyle/>
+          <a:p>
+            <a:pPr algn="ctr"/>
+          </a:p>
+        </p:txBody>
+      </p:sp>
+      <p:sp>
+        <p:nvSpPr>
+          <p:cNvPr id="27" name="TextBox 26"/>
+          <p:cNvSpPr txBox="1"/>
+          <p:nvPr/>
+        </p:nvSpPr>
+        <p:spPr>
+          <a:xfrm>
+            <a:off x="9198864" y="1938528"/>
+            <a:ext cx="2286000" cy="292608"/>
+          </a:xfrm>
+          <a:prstGeom prst="rect">
+            <a:avLst/>
+          </a:prstGeom>
+          <a:noFill/>
+        </p:spPr>
+        <p:txBody>
+          <a:bodyPr wrap="square" anchor="t"/>
+          <a:lstStyle/>
+          <a:p>
+            <a:pPr algn="l"/>
+            <a:r>
+              <a:rPr sz="1400" b="0">
+                <a:solidFill>
+                  <a:srgbClr val="389BFF"/>
+                </a:solidFill>
+                <a:latin typeface="Uncage"/>
+                <a:ea typeface="Uncage"/>
+                <a:cs typeface="Uncage"/>
+              </a:rPr>
+              <a:t>04</a:t>
+            </a:r>
+          </a:p>
+        </p:txBody>
+      </p:sp>
+      <p:sp>
+        <p:nvSpPr>
+          <p:cNvPr id="28" name="TextBox 27"/>
+          <p:cNvSpPr txBox="1"/>
+          <p:nvPr/>
+        </p:nvSpPr>
+        <p:spPr>
+          <a:xfrm>
+            <a:off x="9198864" y="2267712"/>
+            <a:ext cx="2331720" cy="365760"/>
+          </a:xfrm>
+          <a:prstGeom prst="rect">
+            <a:avLst/>
+          </a:prstGeom>
+          <a:noFill/>
+        </p:spPr>
+        <p:txBody>
+          <a:bodyPr wrap="square" anchor="t"/>
+          <a:lstStyle/>
+          <a:p>
+            <a:pPr algn="l"/>
+            <a:r>
+              <a:rPr sz="2000" b="0">
+                <a:solidFill>
+                  <a:srgbClr val="1E1E1E"/>
+                </a:solidFill>
+                <a:latin typeface="Uncage"/>
+                <a:ea typeface="Uncage"/>
+                <a:cs typeface="Uncage"/>
+              </a:rPr>
+              <a:t>Сохранить</a:t>
+            </a:r>
+          </a:p>
+        </p:txBody>
+      </p:sp>
+      <p:sp>
+        <p:nvSpPr>
+          <p:cNvPr id="29" name="TextBox 28"/>
+          <p:cNvSpPr txBox="1"/>
+          <p:nvPr/>
+        </p:nvSpPr>
+        <p:spPr>
+          <a:xfrm>
+            <a:off x="9198864" y="2788920"/>
+            <a:ext cx="2359152" cy="868680"/>
+          </a:xfrm>
+          <a:prstGeom prst="rect">
+            <a:avLst/>
+          </a:prstGeom>
+          <a:noFill/>
+        </p:spPr>
+        <p:txBody>
+          <a:bodyPr wrap="square" anchor="t"/>
+          <a:lstStyle/>
+          <a:p>
+            <a:pPr algn="l"/>
+            <a:r>
+              <a:rPr sz="1400" b="0">
+                <a:solidFill>
+                  <a:srgbClr val="777777"/>
+                </a:solidFill>
+                <a:latin typeface="Arial"/>
+                <a:ea typeface="Arial"/>
+                <a:cs typeface="Arial"/>
+              </a:rPr>
+              <a:t>Понятную историю этих изменений.</a:t>
+            </a:r>
+          </a:p>
+        </p:txBody>
+      </p:sp>
+      <p:sp>
+        <p:nvSpPr>
+          <p:cNvPr id="30" name="Rectangle 29"/>
+          <p:cNvSpPr/>
+          <p:nvPr/>
+        </p:nvSpPr>
+        <p:spPr>
+          <a:xfrm>
+            <a:off x="502920" y="4114800"/>
+            <a:ext cx="11173968" cy="1965960"/>
           </a:xfrm>
           <a:prstGeom prst="rect">
             <a:avLst/>
@@ -4347,14 +4542,14 @@
       </p:sp>
       <p:sp>
         <p:nvSpPr>
-          <p:cNvPr id="26" name="TextBox 25"/>
+          <p:cNvPr id="31" name="TextBox 30"/>
           <p:cNvSpPr txBox="1"/>
           <p:nvPr/>
         </p:nvSpPr>
         <p:spPr>
           <a:xfrm>
-            <a:off x="713232" y="5074920"/>
-            <a:ext cx="10789920" cy="777240"/>
+            <a:off x="731520" y="4279392"/>
+            <a:ext cx="10698480" cy="320040"/>
           </a:xfrm>
           <a:prstGeom prst="rect">
             <a:avLst/>
@@ -4362,7 +4557,42 @@
           <a:noFill/>
         </p:spPr>
         <p:txBody>
-          <a:bodyPr wrap="square" anchor="ctr"/>
+          <a:bodyPr wrap="square" anchor="t"/>
+          <a:lstStyle/>
+          <a:p>
+            <a:pPr algn="l"/>
+            <a:r>
+              <a:rPr sz="1800" b="0">
+                <a:solidFill>
+                  <a:srgbClr val="1E1E1E"/>
+                </a:solidFill>
+                <a:latin typeface="Uncage"/>
+                <a:ea typeface="Uncage"/>
+                <a:cs typeface="Uncage"/>
+              </a:rPr>
+              <a:t>Работаем локально, не в Cloud</a:t>
+            </a:r>
+          </a:p>
+        </p:txBody>
+      </p:sp>
+      <p:sp>
+        <p:nvSpPr>
+          <p:cNvPr id="32" name="TextBox 31"/>
+          <p:cNvSpPr txBox="1"/>
+          <p:nvPr/>
+        </p:nvSpPr>
+        <p:spPr>
+          <a:xfrm>
+            <a:off x="731520" y="4709160"/>
+            <a:ext cx="10698480" cy="1143000"/>
+          </a:xfrm>
+          <a:prstGeom prst="rect">
+            <a:avLst/>
+          </a:prstGeom>
+          <a:noFill/>
+        </p:spPr>
+        <p:txBody>
+          <a:bodyPr wrap="square" anchor="t"/>
           <a:lstStyle/>
           <a:p>
             <a:pPr algn="l"/>
@@ -4375,7 +4605,7 @@
                 <a:ea typeface="Arial"/>
                 <a:cs typeface="Arial"/>
               </a:rPr>
-              <a:t>На тестовом туре агенты не используются: там свой минипроцесс в Битриксе. Cursor берите, чтобы разобрать задачу и собрать MVP.</a:t>
+              <a:t>Файлы лежат на вашем компьютере. Cloud для рабочих проектов и корпоративной информации не используем: на одной учётной записи могут работать несколько человек. Не уверены, где вы сейчас, — остановитесь и спросите IT.</a:t>
             </a:r>
           </a:p>
         </p:txBody>
@@ -4516,7 +4746,7 @@
                 <a:ea typeface="Arial"/>
                 <a:cs typeface="Arial"/>
               </a:rPr>
-              <a:t>Главный навык</a:t>
+              <a:t>Как начинать задачу</a:t>
             </a:r>
           </a:p>
         </p:txBody>
@@ -4551,7 +4781,7 @@
                 <a:ea typeface="Uncage"/>
                 <a:cs typeface="Uncage"/>
               </a:rPr>
-              <a:t>Одна задача — четыре части</a:t>
+              <a:t>Сначала план, потом изменения</a:t>
             </a:r>
           </a:p>
         </p:txBody>
@@ -4610,7 +4840,7 @@
                 <a:ea typeface="Arial"/>
                 <a:cs typeface="Arial"/>
               </a:rPr>
-              <a:t>AI Challenge · ОЦО и бэкофис</a:t>
+              <a:t>Бэк-офис и ОЦО · AI Challenge</a:t>
             </a:r>
           </a:p>
         </p:txBody>
@@ -4658,8 +4888,209 @@
         </p:nvSpPr>
         <p:spPr>
           <a:xfrm>
-            <a:off x="502920" y="1170432"/>
-            <a:ext cx="2697480" cy="1965960"/>
+            <a:off x="502920" y="1143000"/>
+            <a:ext cx="6903720" cy="3794760"/>
+          </a:xfrm>
+          <a:prstGeom prst="rect">
+            <a:avLst/>
+          </a:prstGeom>
+          <a:solidFill>
+            <a:srgbClr val="FFFFFF"/>
+          </a:solidFill>
+          <a:ln w="9525">
+            <a:solidFill>
+              <a:srgbClr val="E0E3E8"/>
+            </a:solidFill>
+          </a:ln>
+          <a:effectLst/>
+        </p:spPr>
+        <p:style>
+          <a:lnRef idx="1">
+            <a:schemeClr val="accent1"/>
+          </a:lnRef>
+          <a:fillRef idx="3">
+            <a:schemeClr val="accent1"/>
+          </a:fillRef>
+          <a:effectRef idx="2">
+            <a:schemeClr val="accent1"/>
+          </a:effectRef>
+          <a:fontRef idx="minor">
+            <a:schemeClr val="lt1"/>
+          </a:fontRef>
+        </p:style>
+        <p:txBody>
+          <a:bodyPr rtlCol="0" anchor="ctr"/>
+          <a:lstStyle/>
+          <a:p>
+            <a:pPr algn="ctr"/>
+          </a:p>
+        </p:txBody>
+      </p:sp>
+      <p:sp>
+        <p:nvSpPr>
+          <p:cNvPr id="10" name="Rectangle 9"/>
+          <p:cNvSpPr/>
+          <p:nvPr/>
+        </p:nvSpPr>
+        <p:spPr>
+          <a:xfrm>
+            <a:off x="502920" y="1143000"/>
+            <a:ext cx="6903720" cy="38100"/>
+          </a:xfrm>
+          <a:prstGeom prst="rect">
+            <a:avLst/>
+          </a:prstGeom>
+          <a:solidFill>
+            <a:srgbClr val="389BFF"/>
+          </a:solidFill>
+          <a:ln>
+            <a:noFill/>
+          </a:ln>
+          <a:effectLst/>
+        </p:spPr>
+        <p:style>
+          <a:lnRef idx="1">
+            <a:schemeClr val="accent1"/>
+          </a:lnRef>
+          <a:fillRef idx="3">
+            <a:schemeClr val="accent1"/>
+          </a:fillRef>
+          <a:effectRef idx="2">
+            <a:schemeClr val="accent1"/>
+          </a:effectRef>
+          <a:fontRef idx="minor">
+            <a:schemeClr val="lt1"/>
+          </a:fontRef>
+        </p:style>
+        <p:txBody>
+          <a:bodyPr rtlCol="0" anchor="ctr"/>
+          <a:lstStyle/>
+          <a:p>
+            <a:pPr algn="ctr"/>
+          </a:p>
+        </p:txBody>
+      </p:sp>
+      <p:sp>
+        <p:nvSpPr>
+          <p:cNvPr id="11" name="TextBox 10"/>
+          <p:cNvSpPr txBox="1"/>
+          <p:nvPr/>
+        </p:nvSpPr>
+        <p:spPr>
+          <a:xfrm>
+            <a:off x="731520" y="1371600"/>
+            <a:ext cx="6446520" cy="3383280"/>
+          </a:xfrm>
+          <a:prstGeom prst="rect">
+            <a:avLst/>
+          </a:prstGeom>
+          <a:noFill/>
+        </p:spPr>
+        <p:txBody>
+          <a:bodyPr wrap="square" anchor="t"/>
+          <a:lstStyle/>
+          <a:p>
+            <a:pPr algn="l">
+              <a:spcAft>
+                <a:spcPts val="1400"/>
+              </a:spcAft>
+            </a:pPr>
+            <a:r>
+              <a:rPr sz="1600" b="0">
+                <a:solidFill>
+                  <a:srgbClr val="1E1E1E"/>
+                </a:solidFill>
+                <a:latin typeface="Arial"/>
+                <a:ea typeface="Arial"/>
+                <a:cs typeface="Arial"/>
+              </a:rPr>
+              <a:t>01   Опишите задачу своими словами.</a:t>
+            </a:r>
+          </a:p>
+          <a:p>
+            <a:pPr algn="l">
+              <a:spcAft>
+                <a:spcPts val="1400"/>
+              </a:spcAft>
+            </a:pPr>
+            <a:r>
+              <a:rPr sz="1600" b="0">
+                <a:solidFill>
+                  <a:srgbClr val="1E1E1E"/>
+                </a:solidFill>
+                <a:latin typeface="Arial"/>
+                <a:ea typeface="Arial"/>
+                <a:cs typeface="Arial"/>
+              </a:rPr>
+              <a:t>02   Попросите изучить, как сделано сейчас, и пока не менять файлы.</a:t>
+            </a:r>
+          </a:p>
+          <a:p>
+            <a:pPr algn="l">
+              <a:spcAft>
+                <a:spcPts val="1400"/>
+              </a:spcAft>
+            </a:pPr>
+            <a:r>
+              <a:rPr sz="1600" b="0">
+                <a:solidFill>
+                  <a:srgbClr val="1E1E1E"/>
+                </a:solidFill>
+                <a:latin typeface="Arial"/>
+                <a:ea typeface="Arial"/>
+                <a:cs typeface="Arial"/>
+              </a:rPr>
+              <a:t>03   Попросите пошаговый план.</a:t>
+            </a:r>
+          </a:p>
+          <a:p>
+            <a:pPr algn="l">
+              <a:spcAft>
+                <a:spcPts val="1400"/>
+              </a:spcAft>
+            </a:pPr>
+            <a:r>
+              <a:rPr sz="1600" b="0">
+                <a:solidFill>
+                  <a:srgbClr val="1E1E1E"/>
+                </a:solidFill>
+                <a:latin typeface="Arial"/>
+                <a:ea typeface="Arial"/>
+                <a:cs typeface="Arial"/>
+              </a:rPr>
+              <a:t>04   Сами прочитайте план: всё ли понятно и нет ли лишнего.</a:t>
+            </a:r>
+          </a:p>
+          <a:p>
+            <a:pPr algn="l">
+              <a:spcAft>
+                <a:spcPts val="1400"/>
+              </a:spcAft>
+            </a:pPr>
+            <a:r>
+              <a:rPr sz="1600" b="0">
+                <a:solidFill>
+                  <a:srgbClr val="1E1E1E"/>
+                </a:solidFill>
+                <a:latin typeface="Arial"/>
+                <a:ea typeface="Arial"/>
+                <a:cs typeface="Arial"/>
+              </a:rPr>
+              <a:t>05   Только после этого разрешите изменения.</a:t>
+            </a:r>
+          </a:p>
+        </p:txBody>
+      </p:sp>
+      <p:sp>
+        <p:nvSpPr>
+          <p:cNvPr id="12" name="Rectangle 11"/>
+          <p:cNvSpPr/>
+          <p:nvPr/>
+        </p:nvSpPr>
+        <p:spPr>
+          <a:xfrm>
+            <a:off x="7571231" y="1143000"/>
+            <a:ext cx="4114800" cy="3794760"/>
           </a:xfrm>
           <a:prstGeom prst="rect">
             <a:avLst/>
@@ -4698,14 +5129,14 @@
       </p:sp>
       <p:sp>
         <p:nvSpPr>
-          <p:cNvPr id="10" name="Rectangle 9"/>
+          <p:cNvPr id="13" name="Rectangle 12"/>
           <p:cNvSpPr/>
           <p:nvPr/>
         </p:nvSpPr>
         <p:spPr>
           <a:xfrm>
-            <a:off x="502920" y="1170432"/>
-            <a:ext cx="2697480" cy="38100"/>
+            <a:off x="7571231" y="1143000"/>
+            <a:ext cx="4114800" cy="38100"/>
           </a:xfrm>
           <a:prstGeom prst="rect">
             <a:avLst/>
@@ -4742,14 +5173,14 @@
       </p:sp>
       <p:sp>
         <p:nvSpPr>
-          <p:cNvPr id="11" name="TextBox 10"/>
+          <p:cNvPr id="14" name="TextBox 13"/>
           <p:cNvSpPr txBox="1"/>
           <p:nvPr/>
         </p:nvSpPr>
         <p:spPr>
           <a:xfrm>
-            <a:off x="649224" y="1335024"/>
-            <a:ext cx="2377440" cy="292608"/>
+            <a:off x="7772400" y="1353312"/>
+            <a:ext cx="3749039" cy="640080"/>
           </a:xfrm>
           <a:prstGeom prst="rect">
             <a:avLst/>
@@ -4762,29 +5193,29 @@
           <a:p>
             <a:pPr algn="l"/>
             <a:r>
-              <a:rPr sz="1400" b="0">
-                <a:solidFill>
-                  <a:srgbClr val="389BFF"/>
+              <a:rPr sz="1800" b="0">
+                <a:solidFill>
+                  <a:srgbClr val="1E1E1E"/>
                 </a:solidFill>
                 <a:latin typeface="Uncage"/>
                 <a:ea typeface="Uncage"/>
                 <a:cs typeface="Uncage"/>
               </a:rPr>
-              <a:t>01</a:t>
-            </a:r>
-          </a:p>
-        </p:txBody>
-      </p:sp>
-      <p:sp>
-        <p:nvSpPr>
-          <p:cNvPr id="12" name="TextBox 11"/>
+              <a:t>Задача сложная, если</a:t>
+            </a:r>
+          </a:p>
+        </p:txBody>
+      </p:sp>
+      <p:sp>
+        <p:nvSpPr>
+          <p:cNvPr id="15" name="TextBox 14"/>
           <p:cNvSpPr txBox="1"/>
           <p:nvPr/>
         </p:nvSpPr>
         <p:spPr>
           <a:xfrm>
-            <a:off x="649224" y="1627632"/>
-            <a:ext cx="2377440" cy="365760"/>
+            <a:off x="7772400" y="2057400"/>
+            <a:ext cx="3703320" cy="2651760"/>
           </a:xfrm>
           <a:prstGeom prst="rect">
             <a:avLst/>
@@ -4795,44 +5226,13 @@
           <a:bodyPr wrap="square" anchor="t"/>
           <a:lstStyle/>
           <a:p>
-            <a:pPr algn="l"/>
-            <a:r>
-              <a:rPr sz="1600" b="0">
-                <a:solidFill>
-                  <a:srgbClr val="1E1E1E"/>
-                </a:solidFill>
-                <a:latin typeface="Uncage"/>
-                <a:ea typeface="Uncage"/>
-                <a:cs typeface="Uncage"/>
-              </a:rPr>
-              <a:t>Как сейчас</a:t>
-            </a:r>
-          </a:p>
-        </p:txBody>
-      </p:sp>
-      <p:sp>
-        <p:nvSpPr>
-          <p:cNvPr id="13" name="TextBox 12"/>
-          <p:cNvSpPr txBox="1"/>
-          <p:nvPr/>
-        </p:nvSpPr>
-        <p:spPr>
-          <a:xfrm>
-            <a:off x="649224" y="2084832"/>
-            <a:ext cx="2395728" cy="868680"/>
-          </a:xfrm>
-          <a:prstGeom prst="rect">
-            <a:avLst/>
-          </a:prstGeom>
-          <a:noFill/>
-        </p:spPr>
-        <p:txBody>
-          <a:bodyPr wrap="square" anchor="t"/>
-          <a:lstStyle/>
-          <a:p>
-            <a:pPr algn="l"/>
-            <a:r>
-              <a:rPr sz="1300" b="0">
+            <a:pPr algn="l">
+              <a:spcAft>
+                <a:spcPts val="1000"/>
+              </a:spcAft>
+            </a:pPr>
+            <a:r>
+              <a:rPr sz="1400" b="0">
                 <a:solidFill>
                   <a:srgbClr val="777777"/>
                 </a:solidFill>
@@ -4840,194 +5240,17 @@
                 <a:ea typeface="Arial"/>
                 <a:cs typeface="Arial"/>
               </a:rPr>
-              <a:t>Процесс своими словами: кто, какой шаг, где теряется время.</a:t>
-            </a:r>
-          </a:p>
-        </p:txBody>
-      </p:sp>
-      <p:sp>
-        <p:nvSpPr>
-          <p:cNvPr id="14" name="Rectangle 13"/>
-          <p:cNvSpPr/>
-          <p:nvPr/>
-        </p:nvSpPr>
-        <p:spPr>
-          <a:xfrm>
-            <a:off x="3346704" y="1170432"/>
-            <a:ext cx="2697480" cy="1965960"/>
-          </a:xfrm>
-          <a:prstGeom prst="rect">
-            <a:avLst/>
-          </a:prstGeom>
-          <a:solidFill>
-            <a:srgbClr val="F4F8FC"/>
-          </a:solidFill>
-          <a:ln w="9525">
-            <a:solidFill>
-              <a:srgbClr val="E0E3E8"/>
-            </a:solidFill>
-          </a:ln>
-          <a:effectLst/>
-        </p:spPr>
-        <p:style>
-          <a:lnRef idx="1">
-            <a:schemeClr val="accent1"/>
-          </a:lnRef>
-          <a:fillRef idx="3">
-            <a:schemeClr val="accent1"/>
-          </a:fillRef>
-          <a:effectRef idx="2">
-            <a:schemeClr val="accent1"/>
-          </a:effectRef>
-          <a:fontRef idx="minor">
-            <a:schemeClr val="lt1"/>
-          </a:fontRef>
-        </p:style>
-        <p:txBody>
-          <a:bodyPr rtlCol="0" anchor="ctr"/>
-          <a:lstStyle/>
-          <a:p>
-            <a:pPr algn="ctr"/>
-          </a:p>
-        </p:txBody>
-      </p:sp>
-      <p:sp>
-        <p:nvSpPr>
-          <p:cNvPr id="15" name="Rectangle 14"/>
-          <p:cNvSpPr/>
-          <p:nvPr/>
-        </p:nvSpPr>
-        <p:spPr>
-          <a:xfrm>
-            <a:off x="3346704" y="1170432"/>
-            <a:ext cx="2697480" cy="38100"/>
-          </a:xfrm>
-          <a:prstGeom prst="rect">
-            <a:avLst/>
-          </a:prstGeom>
-          <a:solidFill>
-            <a:srgbClr val="389BFF"/>
-          </a:solidFill>
-          <a:ln>
-            <a:noFill/>
-          </a:ln>
-          <a:effectLst/>
-        </p:spPr>
-        <p:style>
-          <a:lnRef idx="1">
-            <a:schemeClr val="accent1"/>
-          </a:lnRef>
-          <a:fillRef idx="3">
-            <a:schemeClr val="accent1"/>
-          </a:fillRef>
-          <a:effectRef idx="2">
-            <a:schemeClr val="accent1"/>
-          </a:effectRef>
-          <a:fontRef idx="minor">
-            <a:schemeClr val="lt1"/>
-          </a:fontRef>
-        </p:style>
-        <p:txBody>
-          <a:bodyPr rtlCol="0" anchor="ctr"/>
-          <a:lstStyle/>
-          <a:p>
-            <a:pPr algn="ctr"/>
-          </a:p>
-        </p:txBody>
-      </p:sp>
-      <p:sp>
-        <p:nvSpPr>
-          <p:cNvPr id="16" name="TextBox 15"/>
-          <p:cNvSpPr txBox="1"/>
-          <p:nvPr/>
-        </p:nvSpPr>
-        <p:spPr>
-          <a:xfrm>
-            <a:off x="3493008" y="1335024"/>
-            <a:ext cx="2377440" cy="292608"/>
-          </a:xfrm>
-          <a:prstGeom prst="rect">
-            <a:avLst/>
-          </a:prstGeom>
-          <a:noFill/>
-        </p:spPr>
-        <p:txBody>
-          <a:bodyPr wrap="square" anchor="t"/>
-          <a:lstStyle/>
-          <a:p>
-            <a:pPr algn="l"/>
+              <a:t>Затронуто несколько файлов, систем или отделов.</a:t>
+            </a:r>
+          </a:p>
+          <a:p>
+            <a:pPr algn="l">
+              <a:spcAft>
+                <a:spcPts val="1000"/>
+              </a:spcAft>
+            </a:pPr>
             <a:r>
               <a:rPr sz="1400" b="0">
-                <a:solidFill>
-                  <a:srgbClr val="389BFF"/>
-                </a:solidFill>
-                <a:latin typeface="Uncage"/>
-                <a:ea typeface="Uncage"/>
-                <a:cs typeface="Uncage"/>
-              </a:rPr>
-              <a:t>02</a:t>
-            </a:r>
-          </a:p>
-        </p:txBody>
-      </p:sp>
-      <p:sp>
-        <p:nvSpPr>
-          <p:cNvPr id="17" name="TextBox 16"/>
-          <p:cNvSpPr txBox="1"/>
-          <p:nvPr/>
-        </p:nvSpPr>
-        <p:spPr>
-          <a:xfrm>
-            <a:off x="3493008" y="1627632"/>
-            <a:ext cx="2377440" cy="365760"/>
-          </a:xfrm>
-          <a:prstGeom prst="rect">
-            <a:avLst/>
-          </a:prstGeom>
-          <a:noFill/>
-        </p:spPr>
-        <p:txBody>
-          <a:bodyPr wrap="square" anchor="t"/>
-          <a:lstStyle/>
-          <a:p>
-            <a:pPr algn="l"/>
-            <a:r>
-              <a:rPr sz="1600" b="0">
-                <a:solidFill>
-                  <a:srgbClr val="1E1E1E"/>
-                </a:solidFill>
-                <a:latin typeface="Uncage"/>
-                <a:ea typeface="Uncage"/>
-                <a:cs typeface="Uncage"/>
-              </a:rPr>
-              <a:t>Что получить</a:t>
-            </a:r>
-          </a:p>
-        </p:txBody>
-      </p:sp>
-      <p:sp>
-        <p:nvSpPr>
-          <p:cNvPr id="18" name="TextBox 17"/>
-          <p:cNvSpPr txBox="1"/>
-          <p:nvPr/>
-        </p:nvSpPr>
-        <p:spPr>
-          <a:xfrm>
-            <a:off x="3493008" y="2084832"/>
-            <a:ext cx="2395728" cy="868680"/>
-          </a:xfrm>
-          <a:prstGeom prst="rect">
-            <a:avLst/>
-          </a:prstGeom>
-          <a:noFill/>
-        </p:spPr>
-        <p:txBody>
-          <a:bodyPr wrap="square" anchor="t"/>
-          <a:lstStyle/>
-          <a:p>
-            <a:pPr algn="l"/>
-            <a:r>
-              <a:rPr sz="1300" b="0">
                 <a:solidFill>
                   <a:srgbClr val="777777"/>
                 </a:solidFill>
@@ -5035,194 +5258,17 @@
                 <a:ea typeface="Arial"/>
                 <a:cs typeface="Arial"/>
               </a:rPr>
-              <a:t>Что должно появиться: форма, статус, маршрут, письмо, отчёт.</a:t>
-            </a:r>
-          </a:p>
-        </p:txBody>
-      </p:sp>
-      <p:sp>
-        <p:nvSpPr>
-          <p:cNvPr id="19" name="Rectangle 18"/>
-          <p:cNvSpPr/>
-          <p:nvPr/>
-        </p:nvSpPr>
-        <p:spPr>
-          <a:xfrm>
-            <a:off x="6190488" y="1170432"/>
-            <a:ext cx="2697480" cy="1965960"/>
-          </a:xfrm>
-          <a:prstGeom prst="rect">
-            <a:avLst/>
-          </a:prstGeom>
-          <a:solidFill>
-            <a:srgbClr val="F4F8FC"/>
-          </a:solidFill>
-          <a:ln w="9525">
-            <a:solidFill>
-              <a:srgbClr val="E0E3E8"/>
-            </a:solidFill>
-          </a:ln>
-          <a:effectLst/>
-        </p:spPr>
-        <p:style>
-          <a:lnRef idx="1">
-            <a:schemeClr val="accent1"/>
-          </a:lnRef>
-          <a:fillRef idx="3">
-            <a:schemeClr val="accent1"/>
-          </a:fillRef>
-          <a:effectRef idx="2">
-            <a:schemeClr val="accent1"/>
-          </a:effectRef>
-          <a:fontRef idx="minor">
-            <a:schemeClr val="lt1"/>
-          </a:fontRef>
-        </p:style>
-        <p:txBody>
-          <a:bodyPr rtlCol="0" anchor="ctr"/>
-          <a:lstStyle/>
-          <a:p>
-            <a:pPr algn="ctr"/>
-          </a:p>
-        </p:txBody>
-      </p:sp>
-      <p:sp>
-        <p:nvSpPr>
-          <p:cNvPr id="20" name="Rectangle 19"/>
-          <p:cNvSpPr/>
-          <p:nvPr/>
-        </p:nvSpPr>
-        <p:spPr>
-          <a:xfrm>
-            <a:off x="6190488" y="1170432"/>
-            <a:ext cx="2697480" cy="38100"/>
-          </a:xfrm>
-          <a:prstGeom prst="rect">
-            <a:avLst/>
-          </a:prstGeom>
-          <a:solidFill>
-            <a:srgbClr val="389BFF"/>
-          </a:solidFill>
-          <a:ln>
-            <a:noFill/>
-          </a:ln>
-          <a:effectLst/>
-        </p:spPr>
-        <p:style>
-          <a:lnRef idx="1">
-            <a:schemeClr val="accent1"/>
-          </a:lnRef>
-          <a:fillRef idx="3">
-            <a:schemeClr val="accent1"/>
-          </a:fillRef>
-          <a:effectRef idx="2">
-            <a:schemeClr val="accent1"/>
-          </a:effectRef>
-          <a:fontRef idx="minor">
-            <a:schemeClr val="lt1"/>
-          </a:fontRef>
-        </p:style>
-        <p:txBody>
-          <a:bodyPr rtlCol="0" anchor="ctr"/>
-          <a:lstStyle/>
-          <a:p>
-            <a:pPr algn="ctr"/>
-          </a:p>
-        </p:txBody>
-      </p:sp>
-      <p:sp>
-        <p:nvSpPr>
-          <p:cNvPr id="21" name="TextBox 20"/>
-          <p:cNvSpPr txBox="1"/>
-          <p:nvPr/>
-        </p:nvSpPr>
-        <p:spPr>
-          <a:xfrm>
-            <a:off x="6336792" y="1335024"/>
-            <a:ext cx="2377440" cy="292608"/>
-          </a:xfrm>
-          <a:prstGeom prst="rect">
-            <a:avLst/>
-          </a:prstGeom>
-          <a:noFill/>
-        </p:spPr>
-        <p:txBody>
-          <a:bodyPr wrap="square" anchor="t"/>
-          <a:lstStyle/>
-          <a:p>
-            <a:pPr algn="l"/>
+              <a:t>Можно сломать уже работающий процесс.</a:t>
+            </a:r>
+          </a:p>
+          <a:p>
+            <a:pPr algn="l">
+              <a:spcAft>
+                <a:spcPts val="1000"/>
+              </a:spcAft>
+            </a:pPr>
             <a:r>
               <a:rPr sz="1400" b="0">
-                <a:solidFill>
-                  <a:srgbClr val="389BFF"/>
-                </a:solidFill>
-                <a:latin typeface="Uncage"/>
-                <a:ea typeface="Uncage"/>
-                <a:cs typeface="Uncage"/>
-              </a:rPr>
-              <a:t>03</a:t>
-            </a:r>
-          </a:p>
-        </p:txBody>
-      </p:sp>
-      <p:sp>
-        <p:nvSpPr>
-          <p:cNvPr id="22" name="TextBox 21"/>
-          <p:cNvSpPr txBox="1"/>
-          <p:nvPr/>
-        </p:nvSpPr>
-        <p:spPr>
-          <a:xfrm>
-            <a:off x="6336792" y="1627632"/>
-            <a:ext cx="2377440" cy="365760"/>
-          </a:xfrm>
-          <a:prstGeom prst="rect">
-            <a:avLst/>
-          </a:prstGeom>
-          <a:noFill/>
-        </p:spPr>
-        <p:txBody>
-          <a:bodyPr wrap="square" anchor="t"/>
-          <a:lstStyle/>
-          <a:p>
-            <a:pPr algn="l"/>
-            <a:r>
-              <a:rPr sz="1600" b="0">
-                <a:solidFill>
-                  <a:srgbClr val="1E1E1E"/>
-                </a:solidFill>
-                <a:latin typeface="Uncage"/>
-                <a:ea typeface="Uncage"/>
-                <a:cs typeface="Uncage"/>
-              </a:rPr>
-              <a:t>Чего нельзя</a:t>
-            </a:r>
-          </a:p>
-        </p:txBody>
-      </p:sp>
-      <p:sp>
-        <p:nvSpPr>
-          <p:cNvPr id="23" name="TextBox 22"/>
-          <p:cNvSpPr txBox="1"/>
-          <p:nvPr/>
-        </p:nvSpPr>
-        <p:spPr>
-          <a:xfrm>
-            <a:off x="6336792" y="2084832"/>
-            <a:ext cx="2395728" cy="868680"/>
-          </a:xfrm>
-          <a:prstGeom prst="rect">
-            <a:avLst/>
-          </a:prstGeom>
-          <a:noFill/>
-        </p:spPr>
-        <p:txBody>
-          <a:bodyPr wrap="square" anchor="t"/>
-          <a:lstStyle/>
-          <a:p>
-            <a:pPr algn="l"/>
-            <a:r>
-              <a:rPr sz="1300" b="0">
                 <a:solidFill>
                   <a:srgbClr val="777777"/>
                 </a:solidFill>
@@ -5230,194 +5276,17 @@
                 <a:ea typeface="Arial"/>
                 <a:cs typeface="Arial"/>
               </a:rPr>
-              <a:t>Боевые данные, лишние системы, то, что трогать не просили.</a:t>
-            </a:r>
-          </a:p>
-        </p:txBody>
-      </p:sp>
-      <p:sp>
-        <p:nvSpPr>
-          <p:cNvPr id="24" name="Rectangle 23"/>
-          <p:cNvSpPr/>
-          <p:nvPr/>
-        </p:nvSpPr>
-        <p:spPr>
-          <a:xfrm>
-            <a:off x="9034272" y="1170432"/>
-            <a:ext cx="2697480" cy="1965960"/>
-          </a:xfrm>
-          <a:prstGeom prst="rect">
-            <a:avLst/>
-          </a:prstGeom>
-          <a:solidFill>
-            <a:srgbClr val="F4F8FC"/>
-          </a:solidFill>
-          <a:ln w="9525">
-            <a:solidFill>
-              <a:srgbClr val="E0E3E8"/>
-            </a:solidFill>
-          </a:ln>
-          <a:effectLst/>
-        </p:spPr>
-        <p:style>
-          <a:lnRef idx="1">
-            <a:schemeClr val="accent1"/>
-          </a:lnRef>
-          <a:fillRef idx="3">
-            <a:schemeClr val="accent1"/>
-          </a:fillRef>
-          <a:effectRef idx="2">
-            <a:schemeClr val="accent1"/>
-          </a:effectRef>
-          <a:fontRef idx="minor">
-            <a:schemeClr val="lt1"/>
-          </a:fontRef>
-        </p:style>
-        <p:txBody>
-          <a:bodyPr rtlCol="0" anchor="ctr"/>
-          <a:lstStyle/>
-          <a:p>
-            <a:pPr algn="ctr"/>
-          </a:p>
-        </p:txBody>
-      </p:sp>
-      <p:sp>
-        <p:nvSpPr>
-          <p:cNvPr id="25" name="Rectangle 24"/>
-          <p:cNvSpPr/>
-          <p:nvPr/>
-        </p:nvSpPr>
-        <p:spPr>
-          <a:xfrm>
-            <a:off x="9034272" y="1170432"/>
-            <a:ext cx="2697480" cy="38100"/>
-          </a:xfrm>
-          <a:prstGeom prst="rect">
-            <a:avLst/>
-          </a:prstGeom>
-          <a:solidFill>
-            <a:srgbClr val="389BFF"/>
-          </a:solidFill>
-          <a:ln>
-            <a:noFill/>
-          </a:ln>
-          <a:effectLst/>
-        </p:spPr>
-        <p:style>
-          <a:lnRef idx="1">
-            <a:schemeClr val="accent1"/>
-          </a:lnRef>
-          <a:fillRef idx="3">
-            <a:schemeClr val="accent1"/>
-          </a:fillRef>
-          <a:effectRef idx="2">
-            <a:schemeClr val="accent1"/>
-          </a:effectRef>
-          <a:fontRef idx="minor">
-            <a:schemeClr val="lt1"/>
-          </a:fontRef>
-        </p:style>
-        <p:txBody>
-          <a:bodyPr rtlCol="0" anchor="ctr"/>
-          <a:lstStyle/>
-          <a:p>
-            <a:pPr algn="ctr"/>
-          </a:p>
-        </p:txBody>
-      </p:sp>
-      <p:sp>
-        <p:nvSpPr>
-          <p:cNvPr id="26" name="TextBox 25"/>
-          <p:cNvSpPr txBox="1"/>
-          <p:nvPr/>
-        </p:nvSpPr>
-        <p:spPr>
-          <a:xfrm>
-            <a:off x="9180576" y="1335024"/>
-            <a:ext cx="2377440" cy="292608"/>
-          </a:xfrm>
-          <a:prstGeom prst="rect">
-            <a:avLst/>
-          </a:prstGeom>
-          <a:noFill/>
-        </p:spPr>
-        <p:txBody>
-          <a:bodyPr wrap="square" anchor="t"/>
-          <a:lstStyle/>
-          <a:p>
-            <a:pPr algn="l"/>
+              <a:t>Нужно менять доступы, данные или настройки.</a:t>
+            </a:r>
+          </a:p>
+          <a:p>
+            <a:pPr algn="l">
+              <a:spcAft>
+                <a:spcPts val="1000"/>
+              </a:spcAft>
+            </a:pPr>
             <a:r>
               <a:rPr sz="1400" b="0">
-                <a:solidFill>
-                  <a:srgbClr val="389BFF"/>
-                </a:solidFill>
-                <a:latin typeface="Uncage"/>
-                <a:ea typeface="Uncage"/>
-                <a:cs typeface="Uncage"/>
-              </a:rPr>
-              <a:t>04</a:t>
-            </a:r>
-          </a:p>
-        </p:txBody>
-      </p:sp>
-      <p:sp>
-        <p:nvSpPr>
-          <p:cNvPr id="27" name="TextBox 26"/>
-          <p:cNvSpPr txBox="1"/>
-          <p:nvPr/>
-        </p:nvSpPr>
-        <p:spPr>
-          <a:xfrm>
-            <a:off x="9180576" y="1627632"/>
-            <a:ext cx="2377440" cy="365760"/>
-          </a:xfrm>
-          <a:prstGeom prst="rect">
-            <a:avLst/>
-          </a:prstGeom>
-          <a:noFill/>
-        </p:spPr>
-        <p:txBody>
-          <a:bodyPr wrap="square" anchor="t"/>
-          <a:lstStyle/>
-          <a:p>
-            <a:pPr algn="l"/>
-            <a:r>
-              <a:rPr sz="1600" b="0">
-                <a:solidFill>
-                  <a:srgbClr val="1E1E1E"/>
-                </a:solidFill>
-                <a:latin typeface="Uncage"/>
-                <a:ea typeface="Uncage"/>
-                <a:cs typeface="Uncage"/>
-              </a:rPr>
-              <a:t>Когда готово</a:t>
-            </a:r>
-          </a:p>
-        </p:txBody>
-      </p:sp>
-      <p:sp>
-        <p:nvSpPr>
-          <p:cNvPr id="28" name="TextBox 27"/>
-          <p:cNvSpPr txBox="1"/>
-          <p:nvPr/>
-        </p:nvSpPr>
-        <p:spPr>
-          <a:xfrm>
-            <a:off x="9180576" y="2084832"/>
-            <a:ext cx="2395728" cy="868680"/>
-          </a:xfrm>
-          <a:prstGeom prst="rect">
-            <a:avLst/>
-          </a:prstGeom>
-          <a:noFill/>
-        </p:spPr>
-        <p:txBody>
-          <a:bodyPr wrap="square" anchor="t"/>
-          <a:lstStyle/>
-          <a:p>
-            <a:pPr algn="l"/>
-            <a:r>
-              <a:rPr sz="1300" b="0">
                 <a:solidFill>
                   <a:srgbClr val="777777"/>
                 </a:solidFill>
@@ -5425,111 +5294,21 @@
                 <a:ea typeface="Arial"/>
                 <a:cs typeface="Arial"/>
               </a:rPr>
-              <a:t>Один сценарий, который вы сами можете пройти от начала до конца.</a:t>
-            </a:r>
-          </a:p>
-        </p:txBody>
-      </p:sp>
-      <p:sp>
-        <p:nvSpPr>
-          <p:cNvPr id="29" name="Rectangle 28"/>
-          <p:cNvSpPr/>
-          <p:nvPr/>
-        </p:nvSpPr>
-        <p:spPr>
-          <a:xfrm>
-            <a:off x="502920" y="3310128"/>
-            <a:ext cx="11173968" cy="1874519"/>
-          </a:xfrm>
-          <a:prstGeom prst="rect">
-            <a:avLst/>
-          </a:prstGeom>
-          <a:solidFill>
-            <a:srgbClr val="FFFFFF"/>
-          </a:solidFill>
-          <a:ln w="9525">
-            <a:solidFill>
-              <a:srgbClr val="E0E3E8"/>
-            </a:solidFill>
-          </a:ln>
-          <a:effectLst/>
-        </p:spPr>
-        <p:style>
-          <a:lnRef idx="1">
-            <a:schemeClr val="accent1"/>
-          </a:lnRef>
-          <a:fillRef idx="3">
-            <a:schemeClr val="accent1"/>
-          </a:fillRef>
-          <a:effectRef idx="2">
-            <a:schemeClr val="accent1"/>
-          </a:effectRef>
-          <a:fontRef idx="minor">
-            <a:schemeClr val="lt1"/>
-          </a:fontRef>
-        </p:style>
-        <p:txBody>
-          <a:bodyPr rtlCol="0" anchor="ctr"/>
-          <a:lstStyle/>
-          <a:p>
-            <a:pPr algn="ctr"/>
-          </a:p>
-        </p:txBody>
-      </p:sp>
-      <p:sp>
-        <p:nvSpPr>
-          <p:cNvPr id="30" name="Rectangle 29"/>
-          <p:cNvSpPr/>
-          <p:nvPr/>
-        </p:nvSpPr>
-        <p:spPr>
-          <a:xfrm>
-            <a:off x="502920" y="3310128"/>
-            <a:ext cx="11173968" cy="38100"/>
-          </a:xfrm>
-          <a:prstGeom prst="rect">
-            <a:avLst/>
-          </a:prstGeom>
-          <a:solidFill>
-            <a:srgbClr val="389BFF"/>
-          </a:solidFill>
-          <a:ln>
-            <a:noFill/>
-          </a:ln>
-          <a:effectLst/>
-        </p:spPr>
-        <p:style>
-          <a:lnRef idx="1">
-            <a:schemeClr val="accent1"/>
-          </a:lnRef>
-          <a:fillRef idx="3">
-            <a:schemeClr val="accent1"/>
-          </a:fillRef>
-          <a:effectRef idx="2">
-            <a:schemeClr val="accent1"/>
-          </a:effectRef>
-          <a:fontRef idx="minor">
-            <a:schemeClr val="lt1"/>
-          </a:fontRef>
-        </p:style>
-        <p:txBody>
-          <a:bodyPr rtlCol="0" anchor="ctr"/>
-          <a:lstStyle/>
-          <a:p>
-            <a:pPr algn="ctr"/>
-          </a:p>
-        </p:txBody>
-      </p:sp>
-      <p:sp>
-        <p:nvSpPr>
-          <p:cNvPr id="31" name="TextBox 30"/>
+              <a:t>Вы сами не до конца понимаете, что изменится.</a:t>
+            </a:r>
+          </a:p>
+        </p:txBody>
+      </p:sp>
+      <p:sp>
+        <p:nvSpPr>
+          <p:cNvPr id="16" name="TextBox 15"/>
           <p:cNvSpPr txBox="1"/>
           <p:nvPr/>
         </p:nvSpPr>
         <p:spPr>
           <a:xfrm>
-            <a:off x="713232" y="3456432"/>
-            <a:ext cx="1828800" cy="274320"/>
+            <a:off x="502920" y="5120640"/>
+            <a:ext cx="11155680" cy="1051560"/>
           </a:xfrm>
           <a:prstGeom prst="rect">
             <a:avLst/>
@@ -5542,85 +5321,15 @@
           <a:p>
             <a:pPr algn="l"/>
             <a:r>
-              <a:rPr sz="1300" b="1">
-                <a:solidFill>
-                  <a:srgbClr val="389BFF"/>
+              <a:rPr sz="1600" b="0">
+                <a:solidFill>
+                  <a:srgbClr val="1E1E1E"/>
                 </a:solidFill>
                 <a:latin typeface="Arial"/>
                 <a:ea typeface="Arial"/>
                 <a:cs typeface="Arial"/>
               </a:rPr>
-              <a:t>Так</a:t>
-            </a:r>
-          </a:p>
-        </p:txBody>
-      </p:sp>
-      <p:sp>
-        <p:nvSpPr>
-          <p:cNvPr id="32" name="TextBox 31"/>
-          <p:cNvSpPr txBox="1"/>
-          <p:nvPr/>
-        </p:nvSpPr>
-        <p:spPr>
-          <a:xfrm>
-            <a:off x="713232" y="3767328"/>
-            <a:ext cx="10744200" cy="1234440"/>
-          </a:xfrm>
-          <a:prstGeom prst="rect">
-            <a:avLst/>
-          </a:prstGeom>
-          <a:noFill/>
-        </p:spPr>
-        <p:txBody>
-          <a:bodyPr wrap="square" anchor="t"/>
-          <a:lstStyle/>
-          <a:p>
-            <a:pPr algn="l"/>
-            <a:r>
-              <a:rPr sz="1600" b="0">
-                <a:solidFill>
-                  <a:srgbClr val="1E1E1E"/>
-                </a:solidFill>
-                <a:latin typeface="Arial"/>
-                <a:ea typeface="Arial"/>
-                <a:cs typeface="Arial"/>
-              </a:rPr>
-              <a:t>«Согласование счёта идёт письмами и таблицей. Собери прототип: заявка, маршрут из трёх шагов и статус. Боевые данные не используй. Готово, когда я пройду путь от заявки до „согласовано“.»</a:t>
-            </a:r>
-          </a:p>
-        </p:txBody>
-      </p:sp>
-      <p:sp>
-        <p:nvSpPr>
-          <p:cNvPr id="33" name="TextBox 32"/>
-          <p:cNvSpPr txBox="1"/>
-          <p:nvPr/>
-        </p:nvSpPr>
-        <p:spPr>
-          <a:xfrm>
-            <a:off x="502920" y="5349240"/>
-            <a:ext cx="11155680" cy="868680"/>
-          </a:xfrm>
-          <a:prstGeom prst="rect">
-            <a:avLst/>
-          </a:prstGeom>
-          <a:noFill/>
-        </p:spPr>
-        <p:txBody>
-          <a:bodyPr wrap="square" anchor="t"/>
-          <a:lstStyle/>
-          <a:p>
-            <a:pPr algn="l"/>
-            <a:r>
-              <a:rPr sz="1400" b="0">
-                <a:solidFill>
-                  <a:srgbClr val="777777"/>
-                </a:solidFill>
-                <a:latin typeface="Arial"/>
-                <a:ea typeface="Arial"/>
-                <a:cs typeface="Arial"/>
-              </a:rPr>
-              <a:t>Не так: «Сделай автоматизацию». Новая тема — новый чат. Если вышло не то, напишите, что именно поправить. Нужный файл укажите через @.</a:t>
+              <a:t>Формула запроса: контекст → что сделать → где можно менять → что нельзя → как проверить. Простую задачу можно пройти короче. Сложную разбирайте самым сильным помощником.</a:t>
             </a:r>
           </a:p>
         </p:txBody>
@@ -5761,7 +5470,7 @@
                 <a:ea typeface="Arial"/>
                 <a:cs typeface="Arial"/>
               </a:rPr>
-              <a:t>Панель агента</a:t>
+              <a:t>Границы</a:t>
             </a:r>
           </a:p>
         </p:txBody>
@@ -5796,7 +5505,7 @@
                 <a:ea typeface="Uncage"/>
                 <a:cs typeface="Uncage"/>
               </a:rPr>
-              <a:t>Три режима, больше пока не нужно</a:t>
+              <a:t>Что помощнику не отдаём</a:t>
             </a:r>
           </a:p>
         </p:txBody>
@@ -5855,7 +5564,7 @@
                 <a:ea typeface="Arial"/>
                 <a:cs typeface="Arial"/>
               </a:rPr>
-              <a:t>AI Challenge · ОЦО и бэкофис</a:t>
+              <a:t>Бэк-офис и ОЦО · AI Challenge</a:t>
             </a:r>
           </a:p>
         </p:txBody>
@@ -5897,49 +5606,14 @@
       </p:sp>
       <p:sp>
         <p:nvSpPr>
-          <p:cNvPr id="9" name="TextBox 8"/>
-          <p:cNvSpPr txBox="1"/>
-          <p:nvPr/>
-        </p:nvSpPr>
-        <p:spPr>
-          <a:xfrm>
-            <a:off x="502920" y="1115568"/>
-            <a:ext cx="11155680" cy="502920"/>
-          </a:xfrm>
-          <a:prstGeom prst="rect">
-            <a:avLst/>
-          </a:prstGeom>
-          <a:noFill/>
-        </p:spPr>
-        <p:txBody>
-          <a:bodyPr wrap="square" anchor="t"/>
-          <a:lstStyle/>
-          <a:p>
-            <a:pPr algn="l"/>
-            <a:r>
-              <a:rPr sz="1600" b="0">
-                <a:solidFill>
-                  <a:srgbClr val="1E1E1E"/>
-                </a:solidFill>
-                <a:latin typeface="Arial"/>
-                <a:ea typeface="Arial"/>
-                <a:cs typeface="Arial"/>
-              </a:rPr>
-              <a:t>Открыть панель: Ctrl+I в Windows, Cmd+I на Mac. Режим — внизу панели или Shift+Tab.</a:t>
-            </a:r>
-          </a:p>
-        </p:txBody>
-      </p:sp>
-      <p:sp>
-        <p:nvSpPr>
-          <p:cNvPr id="10" name="Rectangle 9"/>
+          <p:cNvPr id="9" name="Rectangle 8"/>
           <p:cNvSpPr/>
           <p:nvPr/>
         </p:nvSpPr>
         <p:spPr>
           <a:xfrm>
-            <a:off x="502920" y="1783080"/>
-            <a:ext cx="3611880" cy="2926080"/>
+            <a:off x="502920" y="1170432"/>
+            <a:ext cx="3611880" cy="3794760"/>
           </a:xfrm>
           <a:prstGeom prst="rect">
             <a:avLst/>
@@ -5978,13 +5652,13 @@
       </p:sp>
       <p:sp>
         <p:nvSpPr>
-          <p:cNvPr id="11" name="Rectangle 10"/>
+          <p:cNvPr id="10" name="Rectangle 9"/>
           <p:cNvSpPr/>
           <p:nvPr/>
         </p:nvSpPr>
         <p:spPr>
           <a:xfrm>
-            <a:off x="502920" y="1783080"/>
+            <a:off x="502920" y="1170432"/>
             <a:ext cx="3611880" cy="38100"/>
           </a:xfrm>
           <a:prstGeom prst="rect">
@@ -6022,14 +5696,49 @@
       </p:sp>
       <p:sp>
         <p:nvSpPr>
+          <p:cNvPr id="11" name="TextBox 10"/>
+          <p:cNvSpPr txBox="1"/>
+          <p:nvPr/>
+        </p:nvSpPr>
+        <p:spPr>
+          <a:xfrm>
+            <a:off x="722376" y="1426464"/>
+            <a:ext cx="3154680" cy="640080"/>
+          </a:xfrm>
+          <a:prstGeom prst="rect">
+            <a:avLst/>
+          </a:prstGeom>
+          <a:noFill/>
+        </p:spPr>
+        <p:txBody>
+          <a:bodyPr wrap="square" anchor="t"/>
+          <a:lstStyle/>
+          <a:p>
+            <a:pPr algn="l"/>
+            <a:r>
+              <a:rPr sz="2200" b="0">
+                <a:solidFill>
+                  <a:srgbClr val="1E1E1E"/>
+                </a:solidFill>
+                <a:latin typeface="Uncage"/>
+                <a:ea typeface="Uncage"/>
+                <a:cs typeface="Uncage"/>
+              </a:rPr>
+              <a:t>Секреты</a:t>
+            </a:r>
+          </a:p>
+        </p:txBody>
+      </p:sp>
+      <p:sp>
+        <p:nvSpPr>
           <p:cNvPr id="12" name="TextBox 11"/>
           <p:cNvSpPr txBox="1"/>
           <p:nvPr/>
         </p:nvSpPr>
         <p:spPr>
           <a:xfrm>
-            <a:off x="758952" y="2075688"/>
-            <a:ext cx="3108960" cy="365760"/>
+            <a:off x="722376" y="2221992"/>
+            <a:ext cx="3154680" cy="2468880"/>
           </a:xfrm>
           <a:prstGeom prst="rect">
             <a:avLst/>
@@ -6042,99 +5751,29 @@
           <a:p>
             <a:pPr algn="l"/>
             <a:r>
-              <a:rPr sz="1400" b="1">
-                <a:solidFill>
-                  <a:srgbClr val="389BFF"/>
+              <a:rPr sz="1500" b="0">
+                <a:solidFill>
+                  <a:srgbClr val="777777"/>
                 </a:solidFill>
                 <a:latin typeface="Arial"/>
                 <a:ea typeface="Arial"/>
                 <a:cs typeface="Arial"/>
               </a:rPr>
-              <a:t>Agent</a:t>
-            </a:r>
-          </a:p>
-        </p:txBody>
-      </p:sp>
-      <p:sp>
-        <p:nvSpPr>
-          <p:cNvPr id="13" name="TextBox 12"/>
-          <p:cNvSpPr txBox="1"/>
-          <p:nvPr/>
-        </p:nvSpPr>
-        <p:spPr>
-          <a:xfrm>
-            <a:off x="758952" y="2560320"/>
-            <a:ext cx="3108960" cy="640080"/>
-          </a:xfrm>
-          <a:prstGeom prst="rect">
-            <a:avLst/>
-          </a:prstGeom>
-          <a:noFill/>
-        </p:spPr>
-        <p:txBody>
-          <a:bodyPr wrap="square" anchor="t"/>
-          <a:lstStyle/>
-          <a:p>
-            <a:pPr algn="l"/>
-            <a:r>
-              <a:rPr sz="2200" b="0">
-                <a:solidFill>
-                  <a:srgbClr val="1E1E1E"/>
-                </a:solidFill>
-                <a:latin typeface="Uncage"/>
-                <a:ea typeface="Uncage"/>
-                <a:cs typeface="Uncage"/>
-              </a:rPr>
-              <a:t>Собирает и правит</a:t>
-            </a:r>
-          </a:p>
-        </p:txBody>
-      </p:sp>
-      <p:sp>
-        <p:nvSpPr>
-          <p:cNvPr id="14" name="TextBox 13"/>
-          <p:cNvSpPr txBox="1"/>
-          <p:nvPr/>
-        </p:nvSpPr>
-        <p:spPr>
-          <a:xfrm>
-            <a:off x="758952" y="3337560"/>
-            <a:ext cx="3108960" cy="1188720"/>
-          </a:xfrm>
-          <a:prstGeom prst="rect">
-            <a:avLst/>
-          </a:prstGeom>
-          <a:noFill/>
-        </p:spPr>
-        <p:txBody>
-          <a:bodyPr wrap="square" anchor="t"/>
-          <a:lstStyle/>
-          <a:p>
-            <a:pPr algn="l"/>
-            <a:r>
-              <a:rPr sz="1500" b="0">
-                <a:solidFill>
-                  <a:srgbClr val="777777"/>
-                </a:solidFill>
-                <a:latin typeface="Arial"/>
-                <a:ea typeface="Arial"/>
-                <a:cs typeface="Arial"/>
-              </a:rPr>
-              <a:t>Основной режим. Просите сделать форму, маршрут, текст, правку. Смотрите, какие файлы он затронул.</a:t>
-            </a:r>
-          </a:p>
-        </p:txBody>
-      </p:sp>
-      <p:sp>
-        <p:nvSpPr>
-          <p:cNvPr id="15" name="Rectangle 14"/>
+              <a:t>Пароли, коды и ключи не пишем в чат, не вставляем в запрос и не кладём в историю проекта. Даже если попросите показать пароль. Нужен доступ — Cursor готовит пустой локальный файл, значения вносите вы.</a:t>
+            </a:r>
+          </a:p>
+        </p:txBody>
+      </p:sp>
+      <p:sp>
+        <p:nvSpPr>
+          <p:cNvPr id="13" name="Rectangle 12"/>
           <p:cNvSpPr/>
           <p:nvPr/>
         </p:nvSpPr>
         <p:spPr>
           <a:xfrm>
-            <a:off x="4297680" y="1783080"/>
-            <a:ext cx="3611880" cy="2926080"/>
+            <a:off x="4279392" y="1170432"/>
+            <a:ext cx="3611880" cy="3794760"/>
           </a:xfrm>
           <a:prstGeom prst="rect">
             <a:avLst/>
@@ -6173,13 +5812,13 @@
       </p:sp>
       <p:sp>
         <p:nvSpPr>
-          <p:cNvPr id="16" name="Rectangle 15"/>
+          <p:cNvPr id="14" name="Rectangle 13"/>
           <p:cNvSpPr/>
           <p:nvPr/>
         </p:nvSpPr>
         <p:spPr>
           <a:xfrm>
-            <a:off x="4297680" y="1783080"/>
+            <a:off x="4279392" y="1170432"/>
             <a:ext cx="3611880" cy="38100"/>
           </a:xfrm>
           <a:prstGeom prst="rect">
@@ -6217,14 +5856,14 @@
       </p:sp>
       <p:sp>
         <p:nvSpPr>
-          <p:cNvPr id="17" name="TextBox 16"/>
+          <p:cNvPr id="15" name="TextBox 14"/>
           <p:cNvSpPr txBox="1"/>
           <p:nvPr/>
         </p:nvSpPr>
         <p:spPr>
           <a:xfrm>
-            <a:off x="4553712" y="2075688"/>
-            <a:ext cx="3108960" cy="365760"/>
+            <a:off x="4498848" y="1426464"/>
+            <a:ext cx="3154680" cy="640080"/>
           </a:xfrm>
           <a:prstGeom prst="rect">
             <a:avLst/>
@@ -6237,99 +5876,64 @@
           <a:p>
             <a:pPr algn="l"/>
             <a:r>
-              <a:rPr sz="1400" b="1">
-                <a:solidFill>
-                  <a:srgbClr val="389BFF"/>
+              <a:rPr sz="2200" b="0">
+                <a:solidFill>
+                  <a:srgbClr val="1E1E1E"/>
+                </a:solidFill>
+                <a:latin typeface="Uncage"/>
+                <a:ea typeface="Uncage"/>
+                <a:cs typeface="Uncage"/>
+              </a:rPr>
+              <a:t>Рабочая система</a:t>
+            </a:r>
+          </a:p>
+        </p:txBody>
+      </p:sp>
+      <p:sp>
+        <p:nvSpPr>
+          <p:cNvPr id="16" name="TextBox 15"/>
+          <p:cNvSpPr txBox="1"/>
+          <p:nvPr/>
+        </p:nvSpPr>
+        <p:spPr>
+          <a:xfrm>
+            <a:off x="4498848" y="2221992"/>
+            <a:ext cx="3154680" cy="2468880"/>
+          </a:xfrm>
+          <a:prstGeom prst="rect">
+            <a:avLst/>
+          </a:prstGeom>
+          <a:noFill/>
+        </p:spPr>
+        <p:txBody>
+          <a:bodyPr wrap="square" anchor="t"/>
+          <a:lstStyle/>
+          <a:p>
+            <a:pPr algn="l"/>
+            <a:r>
+              <a:rPr sz="1500" b="0">
+                <a:solidFill>
+                  <a:srgbClr val="777777"/>
                 </a:solidFill>
                 <a:latin typeface="Arial"/>
                 <a:ea typeface="Arial"/>
                 <a:cs typeface="Arial"/>
               </a:rPr>
-              <a:t>Ask</a:t>
-            </a:r>
-          </a:p>
-        </p:txBody>
-      </p:sp>
-      <p:sp>
-        <p:nvSpPr>
-          <p:cNvPr id="18" name="TextBox 17"/>
-          <p:cNvSpPr txBox="1"/>
-          <p:nvPr/>
-        </p:nvSpPr>
-        <p:spPr>
-          <a:xfrm>
-            <a:off x="4553712" y="2560320"/>
-            <a:ext cx="3108960" cy="640080"/>
-          </a:xfrm>
-          <a:prstGeom prst="rect">
-            <a:avLst/>
-          </a:prstGeom>
-          <a:noFill/>
-        </p:spPr>
-        <p:txBody>
-          <a:bodyPr wrap="square" anchor="t"/>
-          <a:lstStyle/>
-          <a:p>
-            <a:pPr algn="l"/>
-            <a:r>
-              <a:rPr sz="2200" b="0">
-                <a:solidFill>
-                  <a:srgbClr val="1E1E1E"/>
-                </a:solidFill>
-                <a:latin typeface="Uncage"/>
-                <a:ea typeface="Uncage"/>
-                <a:cs typeface="Uncage"/>
-              </a:rPr>
-              <a:t>Только объясняет</a:t>
-            </a:r>
-          </a:p>
-        </p:txBody>
-      </p:sp>
-      <p:sp>
-        <p:nvSpPr>
-          <p:cNvPr id="19" name="TextBox 18"/>
-          <p:cNvSpPr txBox="1"/>
-          <p:nvPr/>
-        </p:nvSpPr>
-        <p:spPr>
-          <a:xfrm>
-            <a:off x="4553712" y="3337560"/>
-            <a:ext cx="3108960" cy="1188720"/>
-          </a:xfrm>
-          <a:prstGeom prst="rect">
-            <a:avLst/>
-          </a:prstGeom>
-          <a:noFill/>
-        </p:spPr>
-        <p:txBody>
-          <a:bodyPr wrap="square" anchor="t"/>
-          <a:lstStyle/>
-          <a:p>
-            <a:pPr algn="l"/>
-            <a:r>
-              <a:rPr sz="1500" b="0">
-                <a:solidFill>
-                  <a:srgbClr val="777777"/>
-                </a:solidFill>
-                <a:latin typeface="Arial"/>
-                <a:ea typeface="Arial"/>
-                <a:cs typeface="Arial"/>
-              </a:rPr>
-              <a:t>Файлы не меняет. Спрашивайте, как устроен шаг, что означает поле, где искать. Удобно, прежде чем что-то переписывать.</a:t>
-            </a:r>
-          </a:p>
-        </p:txBody>
-      </p:sp>
-      <p:sp>
-        <p:nvSpPr>
-          <p:cNvPr id="20" name="Rectangle 19"/>
+              <a:t>DEV — здесь пробуем. TEST — здесь проверяем. PROD — система, в которой идёт реальная работа. В неё без отдельного процесса не лезем. Неясно, где вы, — остановитесь и спросите IT.</a:t>
+            </a:r>
+          </a:p>
+        </p:txBody>
+      </p:sp>
+      <p:sp>
+        <p:nvSpPr>
+          <p:cNvPr id="17" name="Rectangle 16"/>
           <p:cNvSpPr/>
           <p:nvPr/>
         </p:nvSpPr>
         <p:spPr>
           <a:xfrm>
-            <a:off x="8092440" y="1783080"/>
-            <a:ext cx="3611880" cy="2926080"/>
+            <a:off x="8055864" y="1170432"/>
+            <a:ext cx="3611880" cy="3794760"/>
           </a:xfrm>
           <a:prstGeom prst="rect">
             <a:avLst/>
@@ -6368,13 +5972,13 @@
       </p:sp>
       <p:sp>
         <p:nvSpPr>
-          <p:cNvPr id="21" name="Rectangle 20"/>
+          <p:cNvPr id="18" name="Rectangle 17"/>
           <p:cNvSpPr/>
           <p:nvPr/>
         </p:nvSpPr>
         <p:spPr>
           <a:xfrm>
-            <a:off x="8092440" y="1783080"/>
+            <a:off x="8055864" y="1170432"/>
             <a:ext cx="3611880" cy="38100"/>
           </a:xfrm>
           <a:prstGeom prst="rect">
@@ -6412,14 +6016,14 @@
       </p:sp>
       <p:sp>
         <p:nvSpPr>
-          <p:cNvPr id="22" name="TextBox 21"/>
+          <p:cNvPr id="19" name="TextBox 18"/>
           <p:cNvSpPr txBox="1"/>
           <p:nvPr/>
         </p:nvSpPr>
         <p:spPr>
           <a:xfrm>
-            <a:off x="8348472" y="2075688"/>
-            <a:ext cx="3108960" cy="365760"/>
+            <a:off x="8275320" y="1426464"/>
+            <a:ext cx="3154680" cy="640080"/>
           </a:xfrm>
           <a:prstGeom prst="rect">
             <a:avLst/>
@@ -6432,29 +6036,64 @@
           <a:p>
             <a:pPr algn="l"/>
             <a:r>
-              <a:rPr sz="1400" b="1">
-                <a:solidFill>
-                  <a:srgbClr val="389BFF"/>
+              <a:rPr sz="2200" b="0">
+                <a:solidFill>
+                  <a:srgbClr val="1E1E1E"/>
+                </a:solidFill>
+                <a:latin typeface="Uncage"/>
+                <a:ea typeface="Uncage"/>
+                <a:cs typeface="Uncage"/>
+              </a:rPr>
+              <a:t>Ядро</a:t>
+            </a:r>
+          </a:p>
+        </p:txBody>
+      </p:sp>
+      <p:sp>
+        <p:nvSpPr>
+          <p:cNvPr id="20" name="TextBox 19"/>
+          <p:cNvSpPr txBox="1"/>
+          <p:nvPr/>
+        </p:nvSpPr>
+        <p:spPr>
+          <a:xfrm>
+            <a:off x="8275320" y="2221992"/>
+            <a:ext cx="3154680" cy="2468880"/>
+          </a:xfrm>
+          <a:prstGeom prst="rect">
+            <a:avLst/>
+          </a:prstGeom>
+          <a:noFill/>
+        </p:spPr>
+        <p:txBody>
+          <a:bodyPr wrap="square" anchor="t"/>
+          <a:lstStyle/>
+          <a:p>
+            <a:pPr algn="l"/>
+            <a:r>
+              <a:rPr sz="1500" b="0">
+                <a:solidFill>
+                  <a:srgbClr val="777777"/>
                 </a:solidFill>
                 <a:latin typeface="Arial"/>
                 <a:ea typeface="Arial"/>
                 <a:cs typeface="Arial"/>
               </a:rPr>
-              <a:t>Plan</a:t>
-            </a:r>
-          </a:p>
-        </p:txBody>
-      </p:sp>
-      <p:sp>
-        <p:nvSpPr>
-          <p:cNvPr id="23" name="TextBox 22"/>
+              <a:t>Заводскую часть системы, чужие библиотеки и файлы не по вашей задаче не меняем. Если без этого никак, Cursor останавливается, объясняет риск и ждёт вашего решения или решения IT.</a:t>
+            </a:r>
+          </a:p>
+        </p:txBody>
+      </p:sp>
+      <p:sp>
+        <p:nvSpPr>
+          <p:cNvPr id="21" name="TextBox 20"/>
           <p:cNvSpPr txBox="1"/>
           <p:nvPr/>
         </p:nvSpPr>
         <p:spPr>
           <a:xfrm>
-            <a:off x="8348472" y="2560320"/>
-            <a:ext cx="3108960" cy="640080"/>
+            <a:off x="502920" y="5166360"/>
+            <a:ext cx="11155680" cy="1005840"/>
           </a:xfrm>
           <a:prstGeom prst="rect">
             <a:avLst/>
@@ -6467,85 +6106,15 @@
           <a:p>
             <a:pPr algn="l"/>
             <a:r>
-              <a:rPr sz="2200" b="0">
+              <a:rPr sz="1600" b="0">
                 <a:solidFill>
                   <a:srgbClr val="1E1E1E"/>
-                </a:solidFill>
-                <a:latin typeface="Uncage"/>
-                <a:ea typeface="Uncage"/>
-                <a:cs typeface="Uncage"/>
-              </a:rPr>
-              <a:t>Сначала план</a:t>
-            </a:r>
-          </a:p>
-        </p:txBody>
-      </p:sp>
-      <p:sp>
-        <p:nvSpPr>
-          <p:cNvPr id="24" name="TextBox 23"/>
-          <p:cNvSpPr txBox="1"/>
-          <p:nvPr/>
-        </p:nvSpPr>
-        <p:spPr>
-          <a:xfrm>
-            <a:off x="8348472" y="3337560"/>
-            <a:ext cx="3108960" cy="1188720"/>
-          </a:xfrm>
-          <a:prstGeom prst="rect">
-            <a:avLst/>
-          </a:prstGeom>
-          <a:noFill/>
-        </p:spPr>
-        <p:txBody>
-          <a:bodyPr wrap="square" anchor="t"/>
-          <a:lstStyle/>
-          <a:p>
-            <a:pPr algn="l"/>
-            <a:r>
-              <a:rPr sz="1500" b="0">
-                <a:solidFill>
-                  <a:srgbClr val="777777"/>
                 </a:solidFill>
                 <a:latin typeface="Arial"/>
                 <a:ea typeface="Arial"/>
                 <a:cs typeface="Arial"/>
               </a:rPr>
-              <a:t>Для большой задачи. Агент уточняет, пишет план, ждёт вашего «да» и только потом собирает. План можно поправить.</a:t>
-            </a:r>
-          </a:p>
-        </p:txBody>
-      </p:sp>
-      <p:sp>
-        <p:nvSpPr>
-          <p:cNvPr id="25" name="TextBox 24"/>
-          <p:cNvSpPr txBox="1"/>
-          <p:nvPr/>
-        </p:nvSpPr>
-        <p:spPr>
-          <a:xfrm>
-            <a:off x="502920" y="4937760"/>
-            <a:ext cx="11155680" cy="1097280"/>
-          </a:xfrm>
-          <a:prstGeom prst="rect">
-            <a:avLst/>
-          </a:prstGeom>
-          <a:noFill/>
-        </p:spPr>
-        <p:txBody>
-          <a:bodyPr wrap="square" anchor="t"/>
-          <a:lstStyle/>
-          <a:p>
-            <a:pPr algn="l"/>
-            <a:r>
-              <a:rPr sz="1600" b="0">
-                <a:solidFill>
-                  <a:srgbClr val="1E1E1E"/>
-                </a:solidFill>
-                <a:latin typeface="Arial"/>
-                <a:ea typeface="Arial"/>
-                <a:cs typeface="Arial"/>
-              </a:rPr>
-              <a:t>Не знаете, с чего начать: откройте Ask и попросите объяснить задачу обычным языком. Когда понятно, что должно получиться, переключайтесь в Plan или сразу в Agent.</a:t>
+              <a:t>Тоже стоп: много удалений, смена доступов, база данных, массовое изменение данных. Если остаётся вопрос «а можно ли это менять?» — менять ещё нельзя.</a:t>
             </a:r>
           </a:p>
         </p:txBody>
@@ -6686,7 +6255,7 @@
                 <a:ea typeface="Arial"/>
                 <a:cs typeface="Arial"/>
               </a:rPr>
-              <a:t>Границы</a:t>
+              <a:t>Как заканчиваем</a:t>
             </a:r>
           </a:p>
         </p:txBody>
@@ -6721,7 +6290,7 @@
                 <a:ea typeface="Uncage"/>
                 <a:cs typeface="Uncage"/>
               </a:rPr>
-              <a:t>Четыре правила на всё время челленджа</a:t>
+              <a:t>«Готово» ещё не значит готово</a:t>
             </a:r>
           </a:p>
         </p:txBody>
@@ -6780,7 +6349,7 @@
                 <a:ea typeface="Arial"/>
                 <a:cs typeface="Arial"/>
               </a:rPr>
-              <a:t>AI Challenge · ОЦО и бэкофис</a:t>
+              <a:t>Бэк-офис и ОЦО · AI Challenge</a:t>
             </a:r>
           </a:p>
         </p:txBody>
@@ -6828,8 +6397,8 @@
         </p:nvSpPr>
         <p:spPr>
           <a:xfrm>
-            <a:off x="502920" y="1170432"/>
-            <a:ext cx="5486400" cy="2148840"/>
+            <a:off x="502920" y="1143000"/>
+            <a:ext cx="5486400" cy="3977639"/>
           </a:xfrm>
           <a:prstGeom prst="rect">
             <a:avLst/>
@@ -6874,7 +6443,7 @@
         </p:nvSpPr>
         <p:spPr>
           <a:xfrm>
-            <a:off x="502920" y="1170432"/>
+            <a:off x="502920" y="1143000"/>
             <a:ext cx="5486400" cy="38100"/>
           </a:xfrm>
           <a:prstGeom prst="rect">
@@ -6918,8 +6487,8 @@
         </p:nvSpPr>
         <p:spPr>
           <a:xfrm>
-            <a:off x="758952" y="1426464"/>
-            <a:ext cx="640080" cy="365760"/>
+            <a:off x="731520" y="1325880"/>
+            <a:ext cx="5029200" cy="365760"/>
           </a:xfrm>
           <a:prstGeom prst="rect">
             <a:avLst/>
@@ -6934,13 +6503,13 @@
             <a:r>
               <a:rPr sz="1800" b="0">
                 <a:solidFill>
-                  <a:srgbClr val="389BFF"/>
+                  <a:srgbClr val="1E1E1E"/>
                 </a:solidFill>
                 <a:latin typeface="Uncage"/>
                 <a:ea typeface="Uncage"/>
                 <a:cs typeface="Uncage"/>
               </a:rPr>
-              <a:t>01</a:t>
+              <a:t>Перед началом</a:t>
             </a:r>
           </a:p>
         </p:txBody>
@@ -6953,8 +6522,8 @@
         </p:nvSpPr>
         <p:spPr>
           <a:xfrm>
-            <a:off x="1463040" y="1444752"/>
-            <a:ext cx="4206240" cy="365760"/>
+            <a:off x="731520" y="1828800"/>
+            <a:ext cx="5029200" cy="3017520"/>
           </a:xfrm>
           <a:prstGeom prst="rect">
             <a:avLst/>
@@ -6965,72 +6534,131 @@
           <a:bodyPr wrap="square" anchor="t"/>
           <a:lstStyle/>
           <a:p>
-            <a:pPr algn="l"/>
-            <a:r>
-              <a:rPr sz="2000" b="0">
+            <a:pPr algn="l">
+              <a:spcAft>
+                <a:spcPts val="800"/>
+              </a:spcAft>
+            </a:pPr>
+            <a:r>
+              <a:rPr sz="1500" b="0">
                 <a:solidFill>
                   <a:srgbClr val="1E1E1E"/>
-                </a:solidFill>
-                <a:latin typeface="Uncage"/>
-                <a:ea typeface="Uncage"/>
-                <a:cs typeface="Uncage"/>
-              </a:rPr>
-              <a:t>Секреты</a:t>
-            </a:r>
-          </a:p>
-        </p:txBody>
-      </p:sp>
-      <p:sp>
-        <p:nvSpPr>
-          <p:cNvPr id="13" name="TextBox 12"/>
-          <p:cNvSpPr txBox="1"/>
-          <p:nvPr/>
-        </p:nvSpPr>
-        <p:spPr>
-          <a:xfrm>
-            <a:off x="758952" y="2039112"/>
-            <a:ext cx="4983480" cy="1051560"/>
-          </a:xfrm>
-          <a:prstGeom prst="rect">
-            <a:avLst/>
-          </a:prstGeom>
-          <a:noFill/>
-        </p:spPr>
-        <p:txBody>
-          <a:bodyPr wrap="square" anchor="t"/>
-          <a:lstStyle/>
-          <a:p>
-            <a:pPr algn="l"/>
-            <a:r>
-              <a:rPr sz="1500" b="0">
-                <a:solidFill>
-                  <a:srgbClr val="777777"/>
                 </a:solidFill>
                 <a:latin typeface="Arial"/>
                 <a:ea typeface="Arial"/>
                 <a:cs typeface="Arial"/>
               </a:rPr>
-              <a:t>Пароли, ключи доступа и коды из писем в сообщение не вставляем. Даже «на один раз» и даже если агент просит.</a:t>
-            </a:r>
-          </a:p>
-        </p:txBody>
-      </p:sp>
-      <p:sp>
-        <p:nvSpPr>
-          <p:cNvPr id="14" name="Rectangle 13"/>
+              <a:t>Работаю локально, не в Cloud.</a:t>
+            </a:r>
+          </a:p>
+          <a:p>
+            <a:pPr algn="l">
+              <a:spcAft>
+                <a:spcPts val="800"/>
+              </a:spcAft>
+            </a:pPr>
+            <a:r>
+              <a:rPr sz="1500" b="0">
+                <a:solidFill>
+                  <a:srgbClr val="1E1E1E"/>
+                </a:solidFill>
+                <a:latin typeface="Arial"/>
+                <a:ea typeface="Arial"/>
+                <a:cs typeface="Arial"/>
+              </a:rPr>
+              <a:t>Понимаю: это DEV, TEST или PROD.</a:t>
+            </a:r>
+          </a:p>
+          <a:p>
+            <a:pPr algn="l">
+              <a:spcAft>
+                <a:spcPts val="800"/>
+              </a:spcAft>
+            </a:pPr>
+            <a:r>
+              <a:rPr sz="1500" b="0">
+                <a:solidFill>
+                  <a:srgbClr val="1E1E1E"/>
+                </a:solidFill>
+                <a:latin typeface="Arial"/>
+                <a:ea typeface="Arial"/>
+                <a:cs typeface="Arial"/>
+              </a:rPr>
+              <a:t>История проекта подключена. Её настраивает IT.</a:t>
+            </a:r>
+          </a:p>
+          <a:p>
+            <a:pPr algn="l">
+              <a:spcAft>
+                <a:spcPts val="800"/>
+              </a:spcAft>
+            </a:pPr>
+            <a:r>
+              <a:rPr sz="1500" b="0">
+                <a:solidFill>
+                  <a:srgbClr val="1E1E1E"/>
+                </a:solidFill>
+                <a:latin typeface="Arial"/>
+                <a:ea typeface="Arial"/>
+                <a:cs typeface="Arial"/>
+              </a:rPr>
+              <a:t>Правило про пароли и ключи включено.</a:t>
+            </a:r>
+          </a:p>
+          <a:p>
+            <a:pPr algn="l">
+              <a:spcAft>
+                <a:spcPts val="800"/>
+              </a:spcAft>
+            </a:pPr>
+            <a:r>
+              <a:rPr sz="1500" b="0">
+                <a:solidFill>
+                  <a:srgbClr val="1E1E1E"/>
+                </a:solidFill>
+                <a:latin typeface="Arial"/>
+                <a:ea typeface="Arial"/>
+                <a:cs typeface="Arial"/>
+              </a:rPr>
+              <a:t>Для сложной задачи сначала есть план.</a:t>
+            </a:r>
+          </a:p>
+          <a:p>
+            <a:pPr algn="l">
+              <a:spcAft>
+                <a:spcPts val="800"/>
+              </a:spcAft>
+            </a:pPr>
+            <a:r>
+              <a:rPr sz="1500" b="0">
+                <a:solidFill>
+                  <a:srgbClr val="1E1E1E"/>
+                </a:solidFill>
+                <a:latin typeface="Arial"/>
+                <a:ea typeface="Arial"/>
+                <a:cs typeface="Arial"/>
+              </a:rPr>
+              <a:t>Понимаю, что именно собираюсь менять.</a:t>
+            </a:r>
+          </a:p>
+        </p:txBody>
+      </p:sp>
+      <p:sp>
+        <p:nvSpPr>
+          <p:cNvPr id="13" name="Rectangle 12"/>
           <p:cNvSpPr/>
           <p:nvPr/>
         </p:nvSpPr>
         <p:spPr>
           <a:xfrm>
-            <a:off x="6190488" y="1170432"/>
-            <a:ext cx="5486400" cy="2148840"/>
+            <a:off x="6172200" y="1143000"/>
+            <a:ext cx="5504688" cy="3977639"/>
           </a:xfrm>
           <a:prstGeom prst="rect">
             <a:avLst/>
           </a:prstGeom>
           <a:solidFill>
-            <a:srgbClr val="FFFFFF"/>
+            <a:srgbClr val="F4F8FC"/>
           </a:solidFill>
           <a:ln w="9525">
             <a:solidFill>
@@ -7063,14 +6691,14 @@
       </p:sp>
       <p:sp>
         <p:nvSpPr>
-          <p:cNvPr id="15" name="Rectangle 14"/>
+          <p:cNvPr id="14" name="Rectangle 13"/>
           <p:cNvSpPr/>
           <p:nvPr/>
         </p:nvSpPr>
         <p:spPr>
           <a:xfrm>
-            <a:off x="6190488" y="1170432"/>
-            <a:ext cx="5486400" cy="38100"/>
+            <a:off x="6172200" y="1143000"/>
+            <a:ext cx="5504688" cy="38100"/>
           </a:xfrm>
           <a:prstGeom prst="rect">
             <a:avLst/>
@@ -7107,14 +6735,14 @@
       </p:sp>
       <p:sp>
         <p:nvSpPr>
-          <p:cNvPr id="16" name="TextBox 15"/>
+          <p:cNvPr id="15" name="TextBox 14"/>
           <p:cNvSpPr txBox="1"/>
           <p:nvPr/>
         </p:nvSpPr>
         <p:spPr>
           <a:xfrm>
-            <a:off x="6446520" y="1426464"/>
-            <a:ext cx="640080" cy="365760"/>
+            <a:off x="6400800" y="1325880"/>
+            <a:ext cx="5029200" cy="365760"/>
           </a:xfrm>
           <a:prstGeom prst="rect">
             <a:avLst/>
@@ -7129,27 +6757,27 @@
             <a:r>
               <a:rPr sz="1800" b="0">
                 <a:solidFill>
-                  <a:srgbClr val="389BFF"/>
+                  <a:srgbClr val="1E1E1E"/>
                 </a:solidFill>
                 <a:latin typeface="Uncage"/>
                 <a:ea typeface="Uncage"/>
                 <a:cs typeface="Uncage"/>
               </a:rPr>
-              <a:t>02</a:t>
-            </a:r>
-          </a:p>
-        </p:txBody>
-      </p:sp>
-      <p:sp>
-        <p:nvSpPr>
-          <p:cNvPr id="17" name="TextBox 16"/>
+              <a:t>После изменений</a:t>
+            </a:r>
+          </a:p>
+        </p:txBody>
+      </p:sp>
+      <p:sp>
+        <p:nvSpPr>
+          <p:cNvPr id="16" name="TextBox 15"/>
           <p:cNvSpPr txBox="1"/>
           <p:nvPr/>
         </p:nvSpPr>
         <p:spPr>
           <a:xfrm>
-            <a:off x="7150608" y="1444752"/>
-            <a:ext cx="4206240" cy="365760"/>
+            <a:off x="6400800" y="1828800"/>
+            <a:ext cx="5029200" cy="3017520"/>
           </a:xfrm>
           <a:prstGeom prst="rect">
             <a:avLst/>
@@ -7160,442 +6788,146 @@
           <a:bodyPr wrap="square" anchor="t"/>
           <a:lstStyle/>
           <a:p>
-            <a:pPr algn="l"/>
-            <a:r>
-              <a:rPr sz="2000" b="0">
+            <a:pPr algn="l">
+              <a:spcAft>
+                <a:spcPts val="800"/>
+              </a:spcAft>
+            </a:pPr>
+            <a:r>
+              <a:rPr sz="1500" b="0">
                 <a:solidFill>
                   <a:srgbClr val="1E1E1E"/>
-                </a:solidFill>
-                <a:latin typeface="Uncage"/>
-                <a:ea typeface="Uncage"/>
-                <a:cs typeface="Uncage"/>
-              </a:rPr>
-              <a:t>Боевые данные</a:t>
-            </a:r>
-          </a:p>
-        </p:txBody>
-      </p:sp>
-      <p:sp>
-        <p:nvSpPr>
-          <p:cNvPr id="18" name="TextBox 17"/>
-          <p:cNvSpPr txBox="1"/>
-          <p:nvPr/>
-        </p:nvSpPr>
-        <p:spPr>
-          <a:xfrm>
-            <a:off x="6446520" y="2039112"/>
-            <a:ext cx="4983480" cy="1051560"/>
-          </a:xfrm>
-          <a:prstGeom prst="rect">
-            <a:avLst/>
-          </a:prstGeom>
-          <a:noFill/>
-        </p:spPr>
-        <p:txBody>
-          <a:bodyPr wrap="square" anchor="t"/>
-          <a:lstStyle/>
-          <a:p>
-            <a:pPr algn="l"/>
-            <a:r>
-              <a:rPr sz="1500" b="0">
-                <a:solidFill>
-                  <a:srgbClr val="777777"/>
                 </a:solidFill>
                 <a:latin typeface="Arial"/>
                 <a:ea typeface="Arial"/>
                 <a:cs typeface="Arial"/>
               </a:rPr>
-              <a:t>Персональные и финансовые данные, выгрузки из рабочих систем и реальные договоры в проект и в чат не выносим.</a:t>
-            </a:r>
-          </a:p>
-        </p:txBody>
-      </p:sp>
-      <p:sp>
-        <p:nvSpPr>
-          <p:cNvPr id="19" name="Rectangle 18"/>
-          <p:cNvSpPr/>
-          <p:nvPr/>
-        </p:nvSpPr>
-        <p:spPr>
-          <a:xfrm>
-            <a:off x="502920" y="3483864"/>
-            <a:ext cx="5486400" cy="2148840"/>
-          </a:xfrm>
-          <a:prstGeom prst="rect">
-            <a:avLst/>
-          </a:prstGeom>
-          <a:solidFill>
-            <a:srgbClr val="FFFFFF"/>
-          </a:solidFill>
-          <a:ln w="9525">
-            <a:solidFill>
-              <a:srgbClr val="E0E3E8"/>
-            </a:solidFill>
-          </a:ln>
-          <a:effectLst/>
-        </p:spPr>
-        <p:style>
-          <a:lnRef idx="1">
-            <a:schemeClr val="accent1"/>
-          </a:lnRef>
-          <a:fillRef idx="3">
-            <a:schemeClr val="accent1"/>
-          </a:fillRef>
-          <a:effectRef idx="2">
-            <a:schemeClr val="accent1"/>
-          </a:effectRef>
-          <a:fontRef idx="minor">
-            <a:schemeClr val="lt1"/>
-          </a:fontRef>
-        </p:style>
-        <p:txBody>
-          <a:bodyPr rtlCol="0" anchor="ctr"/>
-          <a:lstStyle/>
-          <a:p>
-            <a:pPr algn="ctr"/>
-          </a:p>
-        </p:txBody>
-      </p:sp>
-      <p:sp>
-        <p:nvSpPr>
-          <p:cNvPr id="20" name="Rectangle 19"/>
-          <p:cNvSpPr/>
-          <p:nvPr/>
-        </p:nvSpPr>
-        <p:spPr>
-          <a:xfrm>
-            <a:off x="502920" y="3483864"/>
-            <a:ext cx="5486400" cy="38100"/>
-          </a:xfrm>
-          <a:prstGeom prst="rect">
-            <a:avLst/>
-          </a:prstGeom>
-          <a:solidFill>
-            <a:srgbClr val="389BFF"/>
-          </a:solidFill>
-          <a:ln>
-            <a:noFill/>
-          </a:ln>
-          <a:effectLst/>
-        </p:spPr>
-        <p:style>
-          <a:lnRef idx="1">
-            <a:schemeClr val="accent1"/>
-          </a:lnRef>
-          <a:fillRef idx="3">
-            <a:schemeClr val="accent1"/>
-          </a:fillRef>
-          <a:effectRef idx="2">
-            <a:schemeClr val="accent1"/>
-          </a:effectRef>
-          <a:fontRef idx="minor">
-            <a:schemeClr val="lt1"/>
-          </a:fontRef>
-        </p:style>
-        <p:txBody>
-          <a:bodyPr rtlCol="0" anchor="ctr"/>
-          <a:lstStyle/>
-          <a:p>
-            <a:pPr algn="ctr"/>
-          </a:p>
-        </p:txBody>
-      </p:sp>
-      <p:sp>
-        <p:nvSpPr>
-          <p:cNvPr id="21" name="TextBox 20"/>
-          <p:cNvSpPr txBox="1"/>
-          <p:nvPr/>
-        </p:nvSpPr>
-        <p:spPr>
-          <a:xfrm>
-            <a:off x="758952" y="3739896"/>
-            <a:ext cx="640080" cy="365760"/>
-          </a:xfrm>
-          <a:prstGeom prst="rect">
-            <a:avLst/>
-          </a:prstGeom>
-          <a:noFill/>
-        </p:spPr>
-        <p:txBody>
-          <a:bodyPr wrap="square" anchor="t"/>
-          <a:lstStyle/>
-          <a:p>
-            <a:pPr algn="l"/>
-            <a:r>
-              <a:rPr sz="1800" b="0">
-                <a:solidFill>
-                  <a:srgbClr val="389BFF"/>
-                </a:solidFill>
-                <a:latin typeface="Uncage"/>
-                <a:ea typeface="Uncage"/>
-                <a:cs typeface="Uncage"/>
-              </a:rPr>
-              <a:t>03</a:t>
-            </a:r>
-          </a:p>
-        </p:txBody>
-      </p:sp>
-      <p:sp>
-        <p:nvSpPr>
-          <p:cNvPr id="22" name="TextBox 21"/>
-          <p:cNvSpPr txBox="1"/>
-          <p:nvPr/>
-        </p:nvSpPr>
-        <p:spPr>
-          <a:xfrm>
-            <a:off x="1463040" y="3758184"/>
-            <a:ext cx="4206240" cy="365760"/>
-          </a:xfrm>
-          <a:prstGeom prst="rect">
-            <a:avLst/>
-          </a:prstGeom>
-          <a:noFill/>
-        </p:spPr>
-        <p:txBody>
-          <a:bodyPr wrap="square" anchor="t"/>
-          <a:lstStyle/>
-          <a:p>
-            <a:pPr algn="l"/>
-            <a:r>
-              <a:rPr sz="2000" b="0">
+              <a:t>Посмотрел, какие файлы изменились.</a:t>
+            </a:r>
+          </a:p>
+          <a:p>
+            <a:pPr algn="l">
+              <a:spcAft>
+                <a:spcPts val="800"/>
+              </a:spcAft>
+            </a:pPr>
+            <a:r>
+              <a:rPr sz="1500" b="0">
                 <a:solidFill>
                   <a:srgbClr val="1E1E1E"/>
-                </a:solidFill>
-                <a:latin typeface="Uncage"/>
-                <a:ea typeface="Uncage"/>
-                <a:cs typeface="Uncage"/>
-              </a:rPr>
-              <a:t>Только Dev</a:t>
-            </a:r>
-          </a:p>
-        </p:txBody>
-      </p:sp>
-      <p:sp>
-        <p:nvSpPr>
-          <p:cNvPr id="23" name="TextBox 22"/>
-          <p:cNvSpPr txBox="1"/>
-          <p:nvPr/>
-        </p:nvSpPr>
-        <p:spPr>
-          <a:xfrm>
-            <a:off x="758952" y="4352544"/>
-            <a:ext cx="4983480" cy="1051560"/>
-          </a:xfrm>
-          <a:prstGeom prst="rect">
-            <a:avLst/>
-          </a:prstGeom>
-          <a:noFill/>
-        </p:spPr>
-        <p:txBody>
-          <a:bodyPr wrap="square" anchor="t"/>
-          <a:lstStyle/>
-          <a:p>
-            <a:pPr algn="l"/>
-            <a:r>
-              <a:rPr sz="1500" b="0">
-                <a:solidFill>
-                  <a:srgbClr val="777777"/>
                 </a:solidFill>
                 <a:latin typeface="Arial"/>
                 <a:ea typeface="Arial"/>
                 <a:cs typeface="Arial"/>
               </a:rPr>
-              <a:t>Прототип собираем на тестовых стендах: Bitrix Dev и Work IT Dev. На рабочий контур сами не переносим.</a:t>
-            </a:r>
-          </a:p>
-        </p:txBody>
-      </p:sp>
-      <p:sp>
-        <p:nvSpPr>
-          <p:cNvPr id="24" name="Rectangle 23"/>
-          <p:cNvSpPr/>
-          <p:nvPr/>
-        </p:nvSpPr>
-        <p:spPr>
-          <a:xfrm>
-            <a:off x="6190488" y="3483864"/>
-            <a:ext cx="5486400" cy="2148840"/>
-          </a:xfrm>
-          <a:prstGeom prst="rect">
-            <a:avLst/>
-          </a:prstGeom>
-          <a:solidFill>
-            <a:srgbClr val="FFFFFF"/>
-          </a:solidFill>
-          <a:ln w="9525">
-            <a:solidFill>
-              <a:srgbClr val="E0E3E8"/>
-            </a:solidFill>
-          </a:ln>
-          <a:effectLst/>
-        </p:spPr>
-        <p:style>
-          <a:lnRef idx="1">
-            <a:schemeClr val="accent1"/>
-          </a:lnRef>
-          <a:fillRef idx="3">
-            <a:schemeClr val="accent1"/>
-          </a:fillRef>
-          <a:effectRef idx="2">
-            <a:schemeClr val="accent1"/>
-          </a:effectRef>
-          <a:fontRef idx="minor">
-            <a:schemeClr val="lt1"/>
-          </a:fontRef>
-        </p:style>
-        <p:txBody>
-          <a:bodyPr rtlCol="0" anchor="ctr"/>
-          <a:lstStyle/>
-          <a:p>
-            <a:pPr algn="ctr"/>
-          </a:p>
-        </p:txBody>
-      </p:sp>
-      <p:sp>
-        <p:nvSpPr>
-          <p:cNvPr id="25" name="Rectangle 24"/>
-          <p:cNvSpPr/>
-          <p:nvPr/>
-        </p:nvSpPr>
-        <p:spPr>
-          <a:xfrm>
-            <a:off x="6190488" y="3483864"/>
-            <a:ext cx="5486400" cy="38100"/>
-          </a:xfrm>
-          <a:prstGeom prst="rect">
-            <a:avLst/>
-          </a:prstGeom>
-          <a:solidFill>
-            <a:srgbClr val="389BFF"/>
-          </a:solidFill>
-          <a:ln>
-            <a:noFill/>
-          </a:ln>
-          <a:effectLst/>
-        </p:spPr>
-        <p:style>
-          <a:lnRef idx="1">
-            <a:schemeClr val="accent1"/>
-          </a:lnRef>
-          <a:fillRef idx="3">
-            <a:schemeClr val="accent1"/>
-          </a:fillRef>
-          <a:effectRef idx="2">
-            <a:schemeClr val="accent1"/>
-          </a:effectRef>
-          <a:fontRef idx="minor">
-            <a:schemeClr val="lt1"/>
-          </a:fontRef>
-        </p:style>
-        <p:txBody>
-          <a:bodyPr rtlCol="0" anchor="ctr"/>
-          <a:lstStyle/>
-          <a:p>
-            <a:pPr algn="ctr"/>
-          </a:p>
-        </p:txBody>
-      </p:sp>
-      <p:sp>
-        <p:nvSpPr>
-          <p:cNvPr id="26" name="TextBox 25"/>
-          <p:cNvSpPr txBox="1"/>
-          <p:nvPr/>
-        </p:nvSpPr>
-        <p:spPr>
-          <a:xfrm>
-            <a:off x="6446520" y="3739896"/>
-            <a:ext cx="640080" cy="365760"/>
-          </a:xfrm>
-          <a:prstGeom prst="rect">
-            <a:avLst/>
-          </a:prstGeom>
-          <a:noFill/>
-        </p:spPr>
-        <p:txBody>
-          <a:bodyPr wrap="square" anchor="t"/>
-          <a:lstStyle/>
-          <a:p>
-            <a:pPr algn="l"/>
-            <a:r>
-              <a:rPr sz="1800" b="0">
-                <a:solidFill>
-                  <a:srgbClr val="389BFF"/>
-                </a:solidFill>
-                <a:latin typeface="Uncage"/>
-                <a:ea typeface="Uncage"/>
-                <a:cs typeface="Uncage"/>
-              </a:rPr>
-              <a:t>04</a:t>
-            </a:r>
-          </a:p>
-        </p:txBody>
-      </p:sp>
-      <p:sp>
-        <p:nvSpPr>
-          <p:cNvPr id="27" name="TextBox 26"/>
-          <p:cNvSpPr txBox="1"/>
-          <p:nvPr/>
-        </p:nvSpPr>
-        <p:spPr>
-          <a:xfrm>
-            <a:off x="7150608" y="3758184"/>
-            <a:ext cx="4206240" cy="365760"/>
-          </a:xfrm>
-          <a:prstGeom prst="rect">
-            <a:avLst/>
-          </a:prstGeom>
-          <a:noFill/>
-        </p:spPr>
-        <p:txBody>
-          <a:bodyPr wrap="square" anchor="t"/>
-          <a:lstStyle/>
-          <a:p>
-            <a:pPr algn="l"/>
-            <a:r>
-              <a:rPr sz="2000" b="0">
+              <a:t>Секреты в историю не попали.</a:t>
+            </a:r>
+          </a:p>
+          <a:p>
+            <a:pPr algn="l">
+              <a:spcAft>
+                <a:spcPts val="800"/>
+              </a:spcAft>
+            </a:pPr>
+            <a:r>
+              <a:rPr sz="1500" b="0">
                 <a:solidFill>
                   <a:srgbClr val="1E1E1E"/>
-                </a:solidFill>
-                <a:latin typeface="Uncage"/>
-                <a:ea typeface="Uncage"/>
-                <a:cs typeface="Uncage"/>
-              </a:rPr>
-              <a:t>Проверка</a:t>
-            </a:r>
-          </a:p>
-        </p:txBody>
-      </p:sp>
-      <p:sp>
-        <p:nvSpPr>
-          <p:cNvPr id="28" name="TextBox 27"/>
-          <p:cNvSpPr txBox="1"/>
-          <p:nvPr/>
-        </p:nvSpPr>
-        <p:spPr>
-          <a:xfrm>
-            <a:off x="6446520" y="4352544"/>
-            <a:ext cx="4983480" cy="1051560"/>
-          </a:xfrm>
-          <a:prstGeom prst="rect">
-            <a:avLst/>
-          </a:prstGeom>
-          <a:noFill/>
-        </p:spPr>
-        <p:txBody>
-          <a:bodyPr wrap="square" anchor="t"/>
-          <a:lstStyle/>
-          <a:p>
-            <a:pPr algn="l"/>
-            <a:r>
-              <a:rPr sz="1500" b="0">
-                <a:solidFill>
-                  <a:srgbClr val="777777"/>
                 </a:solidFill>
                 <a:latin typeface="Arial"/>
                 <a:ea typeface="Arial"/>
                 <a:cs typeface="Arial"/>
               </a:rPr>
-              <a:t>Результат открываете сами и проходите сценарий. Доступы выдаёт ИТ, права в обход не настраиваем.</a:t>
+              <a:t>Основная функция работает.</a:t>
+            </a:r>
+          </a:p>
+          <a:p>
+            <a:pPr algn="l">
+              <a:spcAft>
+                <a:spcPts val="800"/>
+              </a:spcAft>
+            </a:pPr>
+            <a:r>
+              <a:rPr sz="1500" b="0">
+                <a:solidFill>
+                  <a:srgbClr val="1E1E1E"/>
+                </a:solidFill>
+                <a:latin typeface="Arial"/>
+                <a:ea typeface="Arial"/>
+                <a:cs typeface="Arial"/>
+              </a:rPr>
+              <a:t>Соседние процессы не сломались.</a:t>
+            </a:r>
+          </a:p>
+          <a:p>
+            <a:pPr algn="l">
+              <a:spcAft>
+                <a:spcPts val="800"/>
+              </a:spcAft>
+            </a:pPr>
+            <a:r>
+              <a:rPr sz="1500" b="0">
+                <a:solidFill>
+                  <a:srgbClr val="1E1E1E"/>
+                </a:solidFill>
+                <a:latin typeface="Arial"/>
+                <a:ea typeface="Arial"/>
+                <a:cs typeface="Arial"/>
+              </a:rPr>
+              <a:t>Ядро и чужие файлы не тронуты.</a:t>
+            </a:r>
+          </a:p>
+          <a:p>
+            <a:pPr algn="l">
+              <a:spcAft>
+                <a:spcPts val="800"/>
+              </a:spcAft>
+            </a:pPr>
+            <a:r>
+              <a:rPr sz="1500" b="0">
+                <a:solidFill>
+                  <a:srgbClr val="1E1E1E"/>
+                </a:solidFill>
+                <a:latin typeface="Arial"/>
+                <a:ea typeface="Arial"/>
+                <a:cs typeface="Arial"/>
+              </a:rPr>
+              <a:t>Версия сохранена и отправлена в общий проект.</a:t>
+            </a:r>
+          </a:p>
+        </p:txBody>
+      </p:sp>
+      <p:sp>
+        <p:nvSpPr>
+          <p:cNvPr id="17" name="TextBox 16"/>
+          <p:cNvSpPr txBox="1"/>
+          <p:nvPr/>
+        </p:nvSpPr>
+        <p:spPr>
+          <a:xfrm>
+            <a:off x="502920" y="5303520"/>
+            <a:ext cx="11155680" cy="914400"/>
+          </a:xfrm>
+          <a:prstGeom prst="rect">
+            <a:avLst/>
+          </a:prstGeom>
+          <a:noFill/>
+        </p:spPr>
+        <p:txBody>
+          <a:bodyPr wrap="square" anchor="t"/>
+          <a:lstStyle/>
+          <a:p>
+            <a:pPr algn="l"/>
+            <a:r>
+              <a:rPr sz="1600" b="0">
+                <a:solidFill>
+                  <a:srgbClr val="1E1E1E"/>
+                </a:solidFill>
+                <a:latin typeface="Arial"/>
+                <a:ea typeface="Arial"/>
+                <a:cs typeface="Arial"/>
+              </a:rPr>
+              <a:t>Сообщение «готово» не заменяет проверку. Список изменений, сохранение версии и отправка в общий проект — это diff, commit и push. Сомневаетесь — зовём IT.</a:t>
             </a:r>
           </a:p>
         </p:txBody>
@@ -7923,7 +7255,7 @@
                 <a:ea typeface="Arial"/>
                 <a:cs typeface="Arial"/>
               </a:rPr>
-              <a:t>На AI Challenge это ваш знакомый процесс: будущее, которое можно открыть и показать.</a:t>
+              <a:t>Помощник может смениться. Проект остаётся на вашем компьютере, а ответственность за результат — на вас.</a:t>
             </a:r>
           </a:p>
         </p:txBody>

</xml_diff>